<commit_message>
Add estate map and quest journal
Fit interior cameras to the viewport, add accessible quest tracking and live map navigation, extend production smoke coverage, and refresh judge artifacts.
</commit_message>
<xml_diff>
--- a/docs/deck/Kampung SG-Project Introduction Deck-TheTwoGuys.pptx
+++ b/docs/deck/Kampung SG-Project Introduction Deck-TheTwoGuys.pptx
@@ -2,20 +2,20 @@
 <file path=ppt/presentation.xml><?xml version="1.0" encoding="utf-8"?>
 <p:presentation xmlns:p="http://schemas.openxmlformats.org/presentationml/2006/main">
   <p:sldMasterIdLst>
-    <p:sldMasterId xmlns:r="http://schemas.openxmlformats.org/officeDocument/2006/relationships" id="2147483648" r:id="Raae6c11d45d042ed"/>
+    <p:sldMasterId xmlns:r="http://schemas.openxmlformats.org/officeDocument/2006/relationships" id="2147483648" r:id="R9b9762e3eced489e"/>
   </p:sldMasterIdLst>
   <p:notesMasterIdLst>
-    <p:notesMasterId xmlns:r="http://schemas.openxmlformats.org/officeDocument/2006/relationships" r:id="R6cc7c4d962524fb7"/>
+    <p:notesMasterId xmlns:r="http://schemas.openxmlformats.org/officeDocument/2006/relationships" r:id="R02a1d800568b4ad2"/>
   </p:notesMasterIdLst>
   <p:sldIdLst>
-    <p:sldId xmlns:r="http://schemas.openxmlformats.org/officeDocument/2006/relationships" id="256" r:id="R376fa0fdd97d4b74"/>
-    <p:sldId xmlns:r="http://schemas.openxmlformats.org/officeDocument/2006/relationships" id="257" r:id="Rebf77f0e1bd84ff9"/>
-    <p:sldId xmlns:r="http://schemas.openxmlformats.org/officeDocument/2006/relationships" id="258" r:id="R39e90d7077864f58"/>
-    <p:sldId xmlns:r="http://schemas.openxmlformats.org/officeDocument/2006/relationships" id="259" r:id="R95aa5b2118e64907"/>
-    <p:sldId xmlns:r="http://schemas.openxmlformats.org/officeDocument/2006/relationships" id="260" r:id="Rf7fcf17a1f3a42fe"/>
-    <p:sldId xmlns:r="http://schemas.openxmlformats.org/officeDocument/2006/relationships" id="261" r:id="R8143a92ad35f4278"/>
-    <p:sldId xmlns:r="http://schemas.openxmlformats.org/officeDocument/2006/relationships" id="262" r:id="R4119d359e53446a4"/>
-    <p:sldId xmlns:r="http://schemas.openxmlformats.org/officeDocument/2006/relationships" id="263" r:id="R3441c13d0e4b43ee"/>
+    <p:sldId xmlns:r="http://schemas.openxmlformats.org/officeDocument/2006/relationships" id="256" r:id="R297ea9eeec644847"/>
+    <p:sldId xmlns:r="http://schemas.openxmlformats.org/officeDocument/2006/relationships" id="257" r:id="R4baea780991748b2"/>
+    <p:sldId xmlns:r="http://schemas.openxmlformats.org/officeDocument/2006/relationships" id="258" r:id="Rcfabca6b554448a1"/>
+    <p:sldId xmlns:r="http://schemas.openxmlformats.org/officeDocument/2006/relationships" id="259" r:id="R6ccf8ad5bb8247cd"/>
+    <p:sldId xmlns:r="http://schemas.openxmlformats.org/officeDocument/2006/relationships" id="260" r:id="R0c41717a158a496a"/>
+    <p:sldId xmlns:r="http://schemas.openxmlformats.org/officeDocument/2006/relationships" id="261" r:id="Ra022a9f5a7a94962"/>
+    <p:sldId xmlns:r="http://schemas.openxmlformats.org/officeDocument/2006/relationships" id="262" r:id="R3eb1d7a0c10847ae"/>
+    <p:sldId xmlns:r="http://schemas.openxmlformats.org/officeDocument/2006/relationships" id="263" r:id="R8fd1e3288ce646fe"/>
   </p:sldIdLst>
   <p:sldSz cx="12191695" cy="6858000"/>
   <p:notesSz cx="6858000" cy="9144000"/>
@@ -4013,17 +4013,17 @@
   </p:cSld>
   <p:clrMap bg1="lt1" tx1="dk1" bg2="lt2" tx2="dk2" accent1="accent1" accent2="accent2" accent3="accent3" accent4="accent4" accent5="accent5" accent6="accent6" hlink="hlink" folHlink="folHlink"/>
   <p:sldLayoutIdLst>
-    <p:sldLayoutId xmlns:r="http://schemas.openxmlformats.org/officeDocument/2006/relationships" id="2147483649" r:id="R5ae1c77d120e4958"/>
-    <p:sldLayoutId xmlns:r="http://schemas.openxmlformats.org/officeDocument/2006/relationships" id="2147483650" r:id="R4f1055b6757548aa"/>
-    <p:sldLayoutId xmlns:r="http://schemas.openxmlformats.org/officeDocument/2006/relationships" id="2147483651" r:id="Radedf416c2f240c4"/>
-    <p:sldLayoutId xmlns:r="http://schemas.openxmlformats.org/officeDocument/2006/relationships" id="2147483652" r:id="Rb2e84d23834e494b"/>
-    <p:sldLayoutId xmlns:r="http://schemas.openxmlformats.org/officeDocument/2006/relationships" id="2147483653" r:id="R2b386c76f0d34379"/>
-    <p:sldLayoutId xmlns:r="http://schemas.openxmlformats.org/officeDocument/2006/relationships" id="2147483654" r:id="R1521018d173946da"/>
-    <p:sldLayoutId xmlns:r="http://schemas.openxmlformats.org/officeDocument/2006/relationships" id="2147483655" r:id="R027e33dff1514710"/>
-    <p:sldLayoutId xmlns:r="http://schemas.openxmlformats.org/officeDocument/2006/relationships" id="2147483656" r:id="R2b2adeb07d854761"/>
-    <p:sldLayoutId xmlns:r="http://schemas.openxmlformats.org/officeDocument/2006/relationships" id="2147483657" r:id="R866fed1b2e8c4a1c"/>
-    <p:sldLayoutId xmlns:r="http://schemas.openxmlformats.org/officeDocument/2006/relationships" id="2147483658" r:id="R7688e3707b3347d9"/>
-    <p:sldLayoutId xmlns:r="http://schemas.openxmlformats.org/officeDocument/2006/relationships" id="2147483659" r:id="Rdbb60aa595454f41"/>
+    <p:sldLayoutId xmlns:r="http://schemas.openxmlformats.org/officeDocument/2006/relationships" id="2147483649" r:id="R9bb89d86fa554f67"/>
+    <p:sldLayoutId xmlns:r="http://schemas.openxmlformats.org/officeDocument/2006/relationships" id="2147483650" r:id="Rabd3bc50d8ee4718"/>
+    <p:sldLayoutId xmlns:r="http://schemas.openxmlformats.org/officeDocument/2006/relationships" id="2147483651" r:id="Rde0ccdc4d95341cc"/>
+    <p:sldLayoutId xmlns:r="http://schemas.openxmlformats.org/officeDocument/2006/relationships" id="2147483652" r:id="R5acb304234d44051"/>
+    <p:sldLayoutId xmlns:r="http://schemas.openxmlformats.org/officeDocument/2006/relationships" id="2147483653" r:id="R3b83408881854839"/>
+    <p:sldLayoutId xmlns:r="http://schemas.openxmlformats.org/officeDocument/2006/relationships" id="2147483654" r:id="R2a98b9acf86843d9"/>
+    <p:sldLayoutId xmlns:r="http://schemas.openxmlformats.org/officeDocument/2006/relationships" id="2147483655" r:id="Rf911fc4704394e6f"/>
+    <p:sldLayoutId xmlns:r="http://schemas.openxmlformats.org/officeDocument/2006/relationships" id="2147483656" r:id="R02c0a097077e470f"/>
+    <p:sldLayoutId xmlns:r="http://schemas.openxmlformats.org/officeDocument/2006/relationships" id="2147483657" r:id="Rb2c577086ef64136"/>
+    <p:sldLayoutId xmlns:r="http://schemas.openxmlformats.org/officeDocument/2006/relationships" id="2147483658" r:id="Rbecb0fc7360148c8"/>
+    <p:sldLayoutId xmlns:r="http://schemas.openxmlformats.org/officeDocument/2006/relationships" id="2147483659" r:id="R0137e5cb888148d3"/>
   </p:sldLayoutIdLst>
   <p:txStyles>
     <p:titleStyle>
@@ -4534,7 +4534,7 @@
           <p:nvPr/>
         </p:nvPicPr>
         <p:blipFill>
-          <a:blip xmlns:r="http://schemas.openxmlformats.org/officeDocument/2006/relationships" xmlns:a="http://schemas.openxmlformats.org/drawingml/2006/main" r:embed="R316d4130dfcb46b3"/>
+          <a:blip xmlns:r="http://schemas.openxmlformats.org/officeDocument/2006/relationships" xmlns:a="http://schemas.openxmlformats.org/drawingml/2006/main" r:embed="Rc40436eb235b4511"/>
           <a:stretch xmlns:a="http://schemas.openxmlformats.org/drawingml/2006/main">
             <a:fillRect l="0" t="0" r="0" b="0"/>
           </a:stretch>
@@ -4580,7 +4580,7 @@
           <p:nvPr/>
         </p:nvPicPr>
         <p:blipFill>
-          <a:blip xmlns:r="http://schemas.openxmlformats.org/officeDocument/2006/relationships" xmlns:a="http://schemas.openxmlformats.org/drawingml/2006/main" r:embed="R35176511611d4203"/>
+          <a:blip xmlns:r="http://schemas.openxmlformats.org/officeDocument/2006/relationships" xmlns:a="http://schemas.openxmlformats.org/drawingml/2006/main" r:embed="R9e27028c4a1b4568"/>
           <a:stretch xmlns:a="http://schemas.openxmlformats.org/drawingml/2006/main">
             <a:fillRect l="0" t="0" r="0" b="0"/>
           </a:stretch>
@@ -4626,7 +4626,7 @@
           <p:nvPr/>
         </p:nvPicPr>
         <p:blipFill>
-          <a:blip xmlns:r="http://schemas.openxmlformats.org/officeDocument/2006/relationships" xmlns:a="http://schemas.openxmlformats.org/drawingml/2006/main" r:embed="R47265a28f17040e6"/>
+          <a:blip xmlns:r="http://schemas.openxmlformats.org/officeDocument/2006/relationships" xmlns:a="http://schemas.openxmlformats.org/drawingml/2006/main" r:embed="R55b6bba2f11d4e82"/>
           <a:stretch xmlns:a="http://schemas.openxmlformats.org/drawingml/2006/main">
             <a:fillRect l="0" t="0" r="0" b="0"/>
           </a:stretch>
@@ -4672,7 +4672,7 @@
           <p:nvPr/>
         </p:nvPicPr>
         <p:blipFill>
-          <a:blip xmlns:r="http://schemas.openxmlformats.org/officeDocument/2006/relationships" xmlns:a="http://schemas.openxmlformats.org/drawingml/2006/main" r:embed="R2dcbcfb4bfdf4a29"/>
+          <a:blip xmlns:r="http://schemas.openxmlformats.org/officeDocument/2006/relationships" xmlns:a="http://schemas.openxmlformats.org/drawingml/2006/main" r:embed="R7e2e024d272140de"/>
           <a:stretch xmlns:a="http://schemas.openxmlformats.org/drawingml/2006/main">
             <a:fillRect l="0" t="0" r="0" b="0"/>
           </a:stretch>
@@ -4718,7 +4718,7 @@
           <p:nvPr/>
         </p:nvPicPr>
         <p:blipFill>
-          <a:blip xmlns:r="http://schemas.openxmlformats.org/officeDocument/2006/relationships" xmlns:a="http://schemas.openxmlformats.org/drawingml/2006/main" r:embed="R2baa1da9f0ce45a3"/>
+          <a:blip xmlns:r="http://schemas.openxmlformats.org/officeDocument/2006/relationships" xmlns:a="http://schemas.openxmlformats.org/drawingml/2006/main" r:embed="Rc61f10c207b64b31"/>
           <a:stretch xmlns:a="http://schemas.openxmlformats.org/drawingml/2006/main">
             <a:fillRect l="0" t="0" r="0" b="0"/>
           </a:stretch>
@@ -4764,7 +4764,7 @@
           <p:nvPr/>
         </p:nvPicPr>
         <p:blipFill>
-          <a:blip xmlns:r="http://schemas.openxmlformats.org/officeDocument/2006/relationships" xmlns:a="http://schemas.openxmlformats.org/drawingml/2006/main" r:embed="Ree9cde0d5c554fff"/>
+          <a:blip xmlns:r="http://schemas.openxmlformats.org/officeDocument/2006/relationships" xmlns:a="http://schemas.openxmlformats.org/drawingml/2006/main" r:embed="Rde5da90c0f744a77"/>
           <a:stretch xmlns:a="http://schemas.openxmlformats.org/drawingml/2006/main">
             <a:fillRect l="0" t="0" r="0" b="0"/>
           </a:stretch>
@@ -4810,7 +4810,7 @@
           <p:nvPr/>
         </p:nvPicPr>
         <p:blipFill>
-          <a:blip xmlns:r="http://schemas.openxmlformats.org/officeDocument/2006/relationships" xmlns:a="http://schemas.openxmlformats.org/drawingml/2006/main" r:embed="R370d470ede4446e8"/>
+          <a:blip xmlns:r="http://schemas.openxmlformats.org/officeDocument/2006/relationships" xmlns:a="http://schemas.openxmlformats.org/drawingml/2006/main" r:embed="R8aa65c9d83f3473e"/>
           <a:stretch xmlns:a="http://schemas.openxmlformats.org/drawingml/2006/main">
             <a:fillRect l="0" t="0" r="0" b="0"/>
           </a:stretch>
@@ -4856,7 +4856,7 @@
           <p:nvPr/>
         </p:nvPicPr>
         <p:blipFill>
-          <a:blip xmlns:r="http://schemas.openxmlformats.org/officeDocument/2006/relationships" xmlns:a="http://schemas.openxmlformats.org/drawingml/2006/main" r:embed="R25f5a201d1434f05"/>
+          <a:blip xmlns:r="http://schemas.openxmlformats.org/officeDocument/2006/relationships" xmlns:a="http://schemas.openxmlformats.org/drawingml/2006/main" r:embed="R38db9ca21a81426a"/>
           <a:stretch xmlns:a="http://schemas.openxmlformats.org/drawingml/2006/main">
             <a:fillRect l="0" t="0" r="0" b="0"/>
           </a:stretch>

</xml_diff>

<commit_message>
Clarify player controls and estate entrances
</commit_message>
<xml_diff>
--- a/docs/deck/Kampung SG-Project Introduction Deck-TheTwoGuys.pptx
+++ b/docs/deck/Kampung SG-Project Introduction Deck-TheTwoGuys.pptx
@@ -2,20 +2,20 @@
 <file path=ppt/presentation.xml><?xml version="1.0" encoding="utf-8"?>
 <p:presentation xmlns:p="http://schemas.openxmlformats.org/presentationml/2006/main">
   <p:sldMasterIdLst>
-    <p:sldMasterId xmlns:r="http://schemas.openxmlformats.org/officeDocument/2006/relationships" id="2147483648" r:id="R9b9762e3eced489e"/>
+    <p:sldMasterId xmlns:r="http://schemas.openxmlformats.org/officeDocument/2006/relationships" id="2147483648" r:id="Rf02b7a50bb0441b9"/>
   </p:sldMasterIdLst>
   <p:notesMasterIdLst>
-    <p:notesMasterId xmlns:r="http://schemas.openxmlformats.org/officeDocument/2006/relationships" r:id="R02a1d800568b4ad2"/>
+    <p:notesMasterId xmlns:r="http://schemas.openxmlformats.org/officeDocument/2006/relationships" r:id="R452f9c9d3cf54261"/>
   </p:notesMasterIdLst>
   <p:sldIdLst>
-    <p:sldId xmlns:r="http://schemas.openxmlformats.org/officeDocument/2006/relationships" id="256" r:id="R297ea9eeec644847"/>
-    <p:sldId xmlns:r="http://schemas.openxmlformats.org/officeDocument/2006/relationships" id="257" r:id="R4baea780991748b2"/>
-    <p:sldId xmlns:r="http://schemas.openxmlformats.org/officeDocument/2006/relationships" id="258" r:id="Rcfabca6b554448a1"/>
-    <p:sldId xmlns:r="http://schemas.openxmlformats.org/officeDocument/2006/relationships" id="259" r:id="R6ccf8ad5bb8247cd"/>
-    <p:sldId xmlns:r="http://schemas.openxmlformats.org/officeDocument/2006/relationships" id="260" r:id="R0c41717a158a496a"/>
-    <p:sldId xmlns:r="http://schemas.openxmlformats.org/officeDocument/2006/relationships" id="261" r:id="Ra022a9f5a7a94962"/>
-    <p:sldId xmlns:r="http://schemas.openxmlformats.org/officeDocument/2006/relationships" id="262" r:id="R3eb1d7a0c10847ae"/>
-    <p:sldId xmlns:r="http://schemas.openxmlformats.org/officeDocument/2006/relationships" id="263" r:id="R8fd1e3288ce646fe"/>
+    <p:sldId xmlns:r="http://schemas.openxmlformats.org/officeDocument/2006/relationships" id="256" r:id="Red35c0ed6f6b4c24"/>
+    <p:sldId xmlns:r="http://schemas.openxmlformats.org/officeDocument/2006/relationships" id="257" r:id="R7c6ed2c9c260449a"/>
+    <p:sldId xmlns:r="http://schemas.openxmlformats.org/officeDocument/2006/relationships" id="258" r:id="R4c5d0bb7d6cf41e5"/>
+    <p:sldId xmlns:r="http://schemas.openxmlformats.org/officeDocument/2006/relationships" id="259" r:id="Rd500229772914e91"/>
+    <p:sldId xmlns:r="http://schemas.openxmlformats.org/officeDocument/2006/relationships" id="260" r:id="R0dcb9fc1ab294bb4"/>
+    <p:sldId xmlns:r="http://schemas.openxmlformats.org/officeDocument/2006/relationships" id="261" r:id="R31dcccc9ab7a4910"/>
+    <p:sldId xmlns:r="http://schemas.openxmlformats.org/officeDocument/2006/relationships" id="262" r:id="Rb0b490140af4463b"/>
+    <p:sldId xmlns:r="http://schemas.openxmlformats.org/officeDocument/2006/relationships" id="263" r:id="Rfe4256723af547c0"/>
   </p:sldIdLst>
   <p:sldSz cx="12191695" cy="6858000"/>
   <p:notesSz cx="6858000" cy="9144000"/>
@@ -4013,17 +4013,17 @@
   </p:cSld>
   <p:clrMap bg1="lt1" tx1="dk1" bg2="lt2" tx2="dk2" accent1="accent1" accent2="accent2" accent3="accent3" accent4="accent4" accent5="accent5" accent6="accent6" hlink="hlink" folHlink="folHlink"/>
   <p:sldLayoutIdLst>
-    <p:sldLayoutId xmlns:r="http://schemas.openxmlformats.org/officeDocument/2006/relationships" id="2147483649" r:id="R9bb89d86fa554f67"/>
-    <p:sldLayoutId xmlns:r="http://schemas.openxmlformats.org/officeDocument/2006/relationships" id="2147483650" r:id="Rabd3bc50d8ee4718"/>
-    <p:sldLayoutId xmlns:r="http://schemas.openxmlformats.org/officeDocument/2006/relationships" id="2147483651" r:id="Rde0ccdc4d95341cc"/>
-    <p:sldLayoutId xmlns:r="http://schemas.openxmlformats.org/officeDocument/2006/relationships" id="2147483652" r:id="R5acb304234d44051"/>
-    <p:sldLayoutId xmlns:r="http://schemas.openxmlformats.org/officeDocument/2006/relationships" id="2147483653" r:id="R3b83408881854839"/>
-    <p:sldLayoutId xmlns:r="http://schemas.openxmlformats.org/officeDocument/2006/relationships" id="2147483654" r:id="R2a98b9acf86843d9"/>
-    <p:sldLayoutId xmlns:r="http://schemas.openxmlformats.org/officeDocument/2006/relationships" id="2147483655" r:id="Rf911fc4704394e6f"/>
-    <p:sldLayoutId xmlns:r="http://schemas.openxmlformats.org/officeDocument/2006/relationships" id="2147483656" r:id="R02c0a097077e470f"/>
-    <p:sldLayoutId xmlns:r="http://schemas.openxmlformats.org/officeDocument/2006/relationships" id="2147483657" r:id="Rb2c577086ef64136"/>
-    <p:sldLayoutId xmlns:r="http://schemas.openxmlformats.org/officeDocument/2006/relationships" id="2147483658" r:id="Rbecb0fc7360148c8"/>
-    <p:sldLayoutId xmlns:r="http://schemas.openxmlformats.org/officeDocument/2006/relationships" id="2147483659" r:id="R0137e5cb888148d3"/>
+    <p:sldLayoutId xmlns:r="http://schemas.openxmlformats.org/officeDocument/2006/relationships" id="2147483649" r:id="Rc7152adab85b4841"/>
+    <p:sldLayoutId xmlns:r="http://schemas.openxmlformats.org/officeDocument/2006/relationships" id="2147483650" r:id="Rfaa65baeca7e4926"/>
+    <p:sldLayoutId xmlns:r="http://schemas.openxmlformats.org/officeDocument/2006/relationships" id="2147483651" r:id="Re401ac4b016d4d08"/>
+    <p:sldLayoutId xmlns:r="http://schemas.openxmlformats.org/officeDocument/2006/relationships" id="2147483652" r:id="R3a4cdf947eb8444d"/>
+    <p:sldLayoutId xmlns:r="http://schemas.openxmlformats.org/officeDocument/2006/relationships" id="2147483653" r:id="R5e25b99f646546d0"/>
+    <p:sldLayoutId xmlns:r="http://schemas.openxmlformats.org/officeDocument/2006/relationships" id="2147483654" r:id="R6574962f6ee64d4a"/>
+    <p:sldLayoutId xmlns:r="http://schemas.openxmlformats.org/officeDocument/2006/relationships" id="2147483655" r:id="Rf3ca89b4280f4848"/>
+    <p:sldLayoutId xmlns:r="http://schemas.openxmlformats.org/officeDocument/2006/relationships" id="2147483656" r:id="R9266b93598ee41a9"/>
+    <p:sldLayoutId xmlns:r="http://schemas.openxmlformats.org/officeDocument/2006/relationships" id="2147483657" r:id="R8656246f700845e4"/>
+    <p:sldLayoutId xmlns:r="http://schemas.openxmlformats.org/officeDocument/2006/relationships" id="2147483658" r:id="R060313ea168448c5"/>
+    <p:sldLayoutId xmlns:r="http://schemas.openxmlformats.org/officeDocument/2006/relationships" id="2147483659" r:id="Re2ba21243d5c4667"/>
   </p:sldLayoutIdLst>
   <p:txStyles>
     <p:titleStyle>
@@ -4534,7 +4534,7 @@
           <p:nvPr/>
         </p:nvPicPr>
         <p:blipFill>
-          <a:blip xmlns:r="http://schemas.openxmlformats.org/officeDocument/2006/relationships" xmlns:a="http://schemas.openxmlformats.org/drawingml/2006/main" r:embed="Rc40436eb235b4511"/>
+          <a:blip xmlns:r="http://schemas.openxmlformats.org/officeDocument/2006/relationships" xmlns:a="http://schemas.openxmlformats.org/drawingml/2006/main" r:embed="R1703f92537b34155"/>
           <a:stretch xmlns:a="http://schemas.openxmlformats.org/drawingml/2006/main">
             <a:fillRect l="0" t="0" r="0" b="0"/>
           </a:stretch>
@@ -4580,7 +4580,7 @@
           <p:nvPr/>
         </p:nvPicPr>
         <p:blipFill>
-          <a:blip xmlns:r="http://schemas.openxmlformats.org/officeDocument/2006/relationships" xmlns:a="http://schemas.openxmlformats.org/drawingml/2006/main" r:embed="R9e27028c4a1b4568"/>
+          <a:blip xmlns:r="http://schemas.openxmlformats.org/officeDocument/2006/relationships" xmlns:a="http://schemas.openxmlformats.org/drawingml/2006/main" r:embed="R94d2ea8c693c4381"/>
           <a:stretch xmlns:a="http://schemas.openxmlformats.org/drawingml/2006/main">
             <a:fillRect l="0" t="0" r="0" b="0"/>
           </a:stretch>
@@ -4626,7 +4626,7 @@
           <p:nvPr/>
         </p:nvPicPr>
         <p:blipFill>
-          <a:blip xmlns:r="http://schemas.openxmlformats.org/officeDocument/2006/relationships" xmlns:a="http://schemas.openxmlformats.org/drawingml/2006/main" r:embed="R55b6bba2f11d4e82"/>
+          <a:blip xmlns:r="http://schemas.openxmlformats.org/officeDocument/2006/relationships" xmlns:a="http://schemas.openxmlformats.org/drawingml/2006/main" r:embed="R6171989a892446f2"/>
           <a:stretch xmlns:a="http://schemas.openxmlformats.org/drawingml/2006/main">
             <a:fillRect l="0" t="0" r="0" b="0"/>
           </a:stretch>
@@ -4672,7 +4672,7 @@
           <p:nvPr/>
         </p:nvPicPr>
         <p:blipFill>
-          <a:blip xmlns:r="http://schemas.openxmlformats.org/officeDocument/2006/relationships" xmlns:a="http://schemas.openxmlformats.org/drawingml/2006/main" r:embed="R7e2e024d272140de"/>
+          <a:blip xmlns:r="http://schemas.openxmlformats.org/officeDocument/2006/relationships" xmlns:a="http://schemas.openxmlformats.org/drawingml/2006/main" r:embed="R458215b7b9c34d26"/>
           <a:stretch xmlns:a="http://schemas.openxmlformats.org/drawingml/2006/main">
             <a:fillRect l="0" t="0" r="0" b="0"/>
           </a:stretch>
@@ -4718,7 +4718,7 @@
           <p:nvPr/>
         </p:nvPicPr>
         <p:blipFill>
-          <a:blip xmlns:r="http://schemas.openxmlformats.org/officeDocument/2006/relationships" xmlns:a="http://schemas.openxmlformats.org/drawingml/2006/main" r:embed="Rc61f10c207b64b31"/>
+          <a:blip xmlns:r="http://schemas.openxmlformats.org/officeDocument/2006/relationships" xmlns:a="http://schemas.openxmlformats.org/drawingml/2006/main" r:embed="R3c970d6c6ab4422e"/>
           <a:stretch xmlns:a="http://schemas.openxmlformats.org/drawingml/2006/main">
             <a:fillRect l="0" t="0" r="0" b="0"/>
           </a:stretch>
@@ -4764,7 +4764,7 @@
           <p:nvPr/>
         </p:nvPicPr>
         <p:blipFill>
-          <a:blip xmlns:r="http://schemas.openxmlformats.org/officeDocument/2006/relationships" xmlns:a="http://schemas.openxmlformats.org/drawingml/2006/main" r:embed="Rde5da90c0f744a77"/>
+          <a:blip xmlns:r="http://schemas.openxmlformats.org/officeDocument/2006/relationships" xmlns:a="http://schemas.openxmlformats.org/drawingml/2006/main" r:embed="R1c472f5b6de34fe1"/>
           <a:stretch xmlns:a="http://schemas.openxmlformats.org/drawingml/2006/main">
             <a:fillRect l="0" t="0" r="0" b="0"/>
           </a:stretch>
@@ -4810,7 +4810,7 @@
           <p:nvPr/>
         </p:nvPicPr>
         <p:blipFill>
-          <a:blip xmlns:r="http://schemas.openxmlformats.org/officeDocument/2006/relationships" xmlns:a="http://schemas.openxmlformats.org/drawingml/2006/main" r:embed="R8aa65c9d83f3473e"/>
+          <a:blip xmlns:r="http://schemas.openxmlformats.org/officeDocument/2006/relationships" xmlns:a="http://schemas.openxmlformats.org/drawingml/2006/main" r:embed="Rd9322fbbe1f6469c"/>
           <a:stretch xmlns:a="http://schemas.openxmlformats.org/drawingml/2006/main">
             <a:fillRect l="0" t="0" r="0" b="0"/>
           </a:stretch>
@@ -4856,7 +4856,7 @@
           <p:nvPr/>
         </p:nvPicPr>
         <p:blipFill>
-          <a:blip xmlns:r="http://schemas.openxmlformats.org/officeDocument/2006/relationships" xmlns:a="http://schemas.openxmlformats.org/drawingml/2006/main" r:embed="R38db9ca21a81426a"/>
+          <a:blip xmlns:r="http://schemas.openxmlformats.org/officeDocument/2006/relationships" xmlns:a="http://schemas.openxmlformats.org/drawingml/2006/main" r:embed="Rc29b6a2c8be044e2"/>
           <a:stretch xmlns:a="http://schemas.openxmlformats.org/drawingml/2006/main">
             <a:fillRect l="0" t="0" r="0" b="0"/>
           </a:stretch>

</xml_diff>

<commit_message>
Give estate buildings shared three-quarter depth
Bake roof planes, side faces, contact shadows, and recessed entries from one audited registry without moving doors or collision shells. Extend browser evidence, refresh documentation and judged artifacts, and retain the green 75-test/60-check gate.
</commit_message>
<xml_diff>
--- a/docs/deck/Kampung SG-Project Introduction Deck-TheTwoGuys.pptx
+++ b/docs/deck/Kampung SG-Project Introduction Deck-TheTwoGuys.pptx
@@ -2,20 +2,20 @@
 <file path=ppt/presentation.xml><?xml version="1.0" encoding="utf-8"?>
 <p:presentation xmlns:p="http://schemas.openxmlformats.org/presentationml/2006/main">
   <p:sldMasterIdLst>
-    <p:sldMasterId xmlns:r="http://schemas.openxmlformats.org/officeDocument/2006/relationships" id="2147483648" r:id="R06f5acf24b844d1a"/>
+    <p:sldMasterId xmlns:r="http://schemas.openxmlformats.org/officeDocument/2006/relationships" id="2147483648" r:id="Rb7f2cd2f24fe4684"/>
   </p:sldMasterIdLst>
   <p:notesMasterIdLst>
-    <p:notesMasterId xmlns:r="http://schemas.openxmlformats.org/officeDocument/2006/relationships" r:id="R2b96b7c02b0f46b6"/>
+    <p:notesMasterId xmlns:r="http://schemas.openxmlformats.org/officeDocument/2006/relationships" r:id="R037b44cdb8854921"/>
   </p:notesMasterIdLst>
   <p:sldIdLst>
-    <p:sldId xmlns:r="http://schemas.openxmlformats.org/officeDocument/2006/relationships" id="256" r:id="R93851f69a922470e"/>
-    <p:sldId xmlns:r="http://schemas.openxmlformats.org/officeDocument/2006/relationships" id="257" r:id="R06328c4a9f5c4033"/>
-    <p:sldId xmlns:r="http://schemas.openxmlformats.org/officeDocument/2006/relationships" id="258" r:id="R4558d06d07db45d4"/>
-    <p:sldId xmlns:r="http://schemas.openxmlformats.org/officeDocument/2006/relationships" id="259" r:id="R77e2f18360a14f88"/>
-    <p:sldId xmlns:r="http://schemas.openxmlformats.org/officeDocument/2006/relationships" id="260" r:id="Ra863decbdba045a2"/>
-    <p:sldId xmlns:r="http://schemas.openxmlformats.org/officeDocument/2006/relationships" id="261" r:id="R919775db47ec4a7f"/>
-    <p:sldId xmlns:r="http://schemas.openxmlformats.org/officeDocument/2006/relationships" id="262" r:id="Rbaf502a9289242be"/>
-    <p:sldId xmlns:r="http://schemas.openxmlformats.org/officeDocument/2006/relationships" id="263" r:id="R07f28009c9624aa5"/>
+    <p:sldId xmlns:r="http://schemas.openxmlformats.org/officeDocument/2006/relationships" id="256" r:id="R6106e07d8f05459e"/>
+    <p:sldId xmlns:r="http://schemas.openxmlformats.org/officeDocument/2006/relationships" id="257" r:id="R5f36cc8919c24ace"/>
+    <p:sldId xmlns:r="http://schemas.openxmlformats.org/officeDocument/2006/relationships" id="258" r:id="R507c66c0e45f4094"/>
+    <p:sldId xmlns:r="http://schemas.openxmlformats.org/officeDocument/2006/relationships" id="259" r:id="R08b28c0c04114654"/>
+    <p:sldId xmlns:r="http://schemas.openxmlformats.org/officeDocument/2006/relationships" id="260" r:id="Rb9b2248bfaed4c29"/>
+    <p:sldId xmlns:r="http://schemas.openxmlformats.org/officeDocument/2006/relationships" id="261" r:id="Ra246e705de954265"/>
+    <p:sldId xmlns:r="http://schemas.openxmlformats.org/officeDocument/2006/relationships" id="262" r:id="Rab9a2cf825094078"/>
+    <p:sldId xmlns:r="http://schemas.openxmlformats.org/officeDocument/2006/relationships" id="263" r:id="R180532b55f184e9c"/>
   </p:sldIdLst>
   <p:sldSz cx="12191695" cy="6858000"/>
   <p:notesSz cx="6858000" cy="9144000"/>
@@ -847,7 +847,7 @@
           <a:lstStyle xmlns:a="http://schemas.openxmlformats.org/drawingml/2006/main"/>
           <a:p xmlns:a="http://schemas.openxmlformats.org/drawingml/2006/main">
             <a:r>
-              <a:t>Our first CodeBuddy run failed its gate, and the correction attempt hit 429 credits exhausted. We preserved that evidence. Three real OpenAI visual workflows also preserve prompts, artifacts and human decisions: two informed code-drawn systems, while the title pass rejected pseudo-writing, constrained the edit and shipped one reviewed panorama. None is claimed as Miora.</a:t>
+              <a:t>Our first CodeBuddy run failed its gate, and the correction attempt hit 429 credits exhausted. We preserved that evidence. Later AI-assisted work added the pure campaign reducer, KampungMind and expanded checks. A real OpenAI image-generation pass produced one visual target; human review rejected direct runtime use and translated its strongest idea into four verified code-drawn activity vignettes. We treat AI output as a pull request, not a deliverable, and we do not relabel this as Miora.</a:t>
             </a:r>
           </a:p>
         </p:txBody>
@@ -4013,17 +4013,17 @@
   </p:cSld>
   <p:clrMap bg1="lt1" tx1="dk1" bg2="lt2" tx2="dk2" accent1="accent1" accent2="accent2" accent3="accent3" accent4="accent4" accent5="accent5" accent6="accent6" hlink="hlink" folHlink="folHlink"/>
   <p:sldLayoutIdLst>
-    <p:sldLayoutId xmlns:r="http://schemas.openxmlformats.org/officeDocument/2006/relationships" id="2147483649" r:id="Rff415aaf80a04285"/>
-    <p:sldLayoutId xmlns:r="http://schemas.openxmlformats.org/officeDocument/2006/relationships" id="2147483650" r:id="Re35c7b0c5b1040bb"/>
-    <p:sldLayoutId xmlns:r="http://schemas.openxmlformats.org/officeDocument/2006/relationships" id="2147483651" r:id="R5a18426f6bd84be6"/>
-    <p:sldLayoutId xmlns:r="http://schemas.openxmlformats.org/officeDocument/2006/relationships" id="2147483652" r:id="R4fe665df98ff4a9a"/>
-    <p:sldLayoutId xmlns:r="http://schemas.openxmlformats.org/officeDocument/2006/relationships" id="2147483653" r:id="R4c6e7149486340f5"/>
-    <p:sldLayoutId xmlns:r="http://schemas.openxmlformats.org/officeDocument/2006/relationships" id="2147483654" r:id="R6784a096c7d44ec4"/>
-    <p:sldLayoutId xmlns:r="http://schemas.openxmlformats.org/officeDocument/2006/relationships" id="2147483655" r:id="Rcd48388b16b64c25"/>
-    <p:sldLayoutId xmlns:r="http://schemas.openxmlformats.org/officeDocument/2006/relationships" id="2147483656" r:id="R6ff3e22dc1e44c1a"/>
-    <p:sldLayoutId xmlns:r="http://schemas.openxmlformats.org/officeDocument/2006/relationships" id="2147483657" r:id="R149f284a17f64d4c"/>
-    <p:sldLayoutId xmlns:r="http://schemas.openxmlformats.org/officeDocument/2006/relationships" id="2147483658" r:id="R07675634bdb74fbd"/>
-    <p:sldLayoutId xmlns:r="http://schemas.openxmlformats.org/officeDocument/2006/relationships" id="2147483659" r:id="R2a25425e60eb4496"/>
+    <p:sldLayoutId xmlns:r="http://schemas.openxmlformats.org/officeDocument/2006/relationships" id="2147483649" r:id="Rb82aa42c8af741f9"/>
+    <p:sldLayoutId xmlns:r="http://schemas.openxmlformats.org/officeDocument/2006/relationships" id="2147483650" r:id="Rd5ecd062d8214819"/>
+    <p:sldLayoutId xmlns:r="http://schemas.openxmlformats.org/officeDocument/2006/relationships" id="2147483651" r:id="R5c14f1fa2a134d74"/>
+    <p:sldLayoutId xmlns:r="http://schemas.openxmlformats.org/officeDocument/2006/relationships" id="2147483652" r:id="Rfe1cb46f10ba4e0d"/>
+    <p:sldLayoutId xmlns:r="http://schemas.openxmlformats.org/officeDocument/2006/relationships" id="2147483653" r:id="R4c8a89721b3c400d"/>
+    <p:sldLayoutId xmlns:r="http://schemas.openxmlformats.org/officeDocument/2006/relationships" id="2147483654" r:id="Re6b6c02075d249d5"/>
+    <p:sldLayoutId xmlns:r="http://schemas.openxmlformats.org/officeDocument/2006/relationships" id="2147483655" r:id="Re73efa3ae0ed42ae"/>
+    <p:sldLayoutId xmlns:r="http://schemas.openxmlformats.org/officeDocument/2006/relationships" id="2147483656" r:id="Rd2f58601855942a6"/>
+    <p:sldLayoutId xmlns:r="http://schemas.openxmlformats.org/officeDocument/2006/relationships" id="2147483657" r:id="R63d9e8800f8340ff"/>
+    <p:sldLayoutId xmlns:r="http://schemas.openxmlformats.org/officeDocument/2006/relationships" id="2147483658" r:id="R7cda7ca28cdc400a"/>
+    <p:sldLayoutId xmlns:r="http://schemas.openxmlformats.org/officeDocument/2006/relationships" id="2147483659" r:id="Rb937578abdc7473c"/>
   </p:sldLayoutIdLst>
   <p:txStyles>
     <p:titleStyle>
@@ -4534,7 +4534,7 @@
           <p:nvPr/>
         </p:nvPicPr>
         <p:blipFill>
-          <a:blip xmlns:r="http://schemas.openxmlformats.org/officeDocument/2006/relationships" xmlns:a="http://schemas.openxmlformats.org/drawingml/2006/main" r:embed="R2b99c102ffba4744"/>
+          <a:blip xmlns:r="http://schemas.openxmlformats.org/officeDocument/2006/relationships" xmlns:a="http://schemas.openxmlformats.org/drawingml/2006/main" r:embed="Rec94f3ebf3564cbc"/>
           <a:stretch xmlns:a="http://schemas.openxmlformats.org/drawingml/2006/main">
             <a:fillRect l="0" t="0" r="0" b="0"/>
           </a:stretch>
@@ -4580,7 +4580,7 @@
           <p:nvPr/>
         </p:nvPicPr>
         <p:blipFill>
-          <a:blip xmlns:r="http://schemas.openxmlformats.org/officeDocument/2006/relationships" xmlns:a="http://schemas.openxmlformats.org/drawingml/2006/main" r:embed="Ra20351aada744e7d"/>
+          <a:blip xmlns:r="http://schemas.openxmlformats.org/officeDocument/2006/relationships" xmlns:a="http://schemas.openxmlformats.org/drawingml/2006/main" r:embed="Rf18456af303e42b1"/>
           <a:stretch xmlns:a="http://schemas.openxmlformats.org/drawingml/2006/main">
             <a:fillRect l="0" t="0" r="0" b="0"/>
           </a:stretch>
@@ -4626,7 +4626,7 @@
           <p:nvPr/>
         </p:nvPicPr>
         <p:blipFill>
-          <a:blip xmlns:r="http://schemas.openxmlformats.org/officeDocument/2006/relationships" xmlns:a="http://schemas.openxmlformats.org/drawingml/2006/main" r:embed="Rc66b157d710444f1"/>
+          <a:blip xmlns:r="http://schemas.openxmlformats.org/officeDocument/2006/relationships" xmlns:a="http://schemas.openxmlformats.org/drawingml/2006/main" r:embed="R345c4c3aa2b5485f"/>
           <a:stretch xmlns:a="http://schemas.openxmlformats.org/drawingml/2006/main">
             <a:fillRect l="0" t="0" r="0" b="0"/>
           </a:stretch>
@@ -4672,7 +4672,7 @@
           <p:nvPr/>
         </p:nvPicPr>
         <p:blipFill>
-          <a:blip xmlns:r="http://schemas.openxmlformats.org/officeDocument/2006/relationships" xmlns:a="http://schemas.openxmlformats.org/drawingml/2006/main" r:embed="R56fd7a05bb174a47"/>
+          <a:blip xmlns:r="http://schemas.openxmlformats.org/officeDocument/2006/relationships" xmlns:a="http://schemas.openxmlformats.org/drawingml/2006/main" r:embed="R920c19da49f74581"/>
           <a:stretch xmlns:a="http://schemas.openxmlformats.org/drawingml/2006/main">
             <a:fillRect l="0" t="0" r="0" b="0"/>
           </a:stretch>
@@ -4718,7 +4718,7 @@
           <p:nvPr/>
         </p:nvPicPr>
         <p:blipFill>
-          <a:blip xmlns:r="http://schemas.openxmlformats.org/officeDocument/2006/relationships" xmlns:a="http://schemas.openxmlformats.org/drawingml/2006/main" r:embed="Rb801ab7c5ad1422d"/>
+          <a:blip xmlns:r="http://schemas.openxmlformats.org/officeDocument/2006/relationships" xmlns:a="http://schemas.openxmlformats.org/drawingml/2006/main" r:embed="Reda50fdbf8994adb"/>
           <a:stretch xmlns:a="http://schemas.openxmlformats.org/drawingml/2006/main">
             <a:fillRect l="0" t="0" r="0" b="0"/>
           </a:stretch>
@@ -4764,7 +4764,7 @@
           <p:nvPr/>
         </p:nvPicPr>
         <p:blipFill>
-          <a:blip xmlns:r="http://schemas.openxmlformats.org/officeDocument/2006/relationships" xmlns:a="http://schemas.openxmlformats.org/drawingml/2006/main" r:embed="Rf3addd2b1a274a5c"/>
+          <a:blip xmlns:r="http://schemas.openxmlformats.org/officeDocument/2006/relationships" xmlns:a="http://schemas.openxmlformats.org/drawingml/2006/main" r:embed="R67fe57c2cfab46be"/>
           <a:stretch xmlns:a="http://schemas.openxmlformats.org/drawingml/2006/main">
             <a:fillRect l="0" t="0" r="0" b="0"/>
           </a:stretch>
@@ -4810,7 +4810,7 @@
           <p:nvPr/>
         </p:nvPicPr>
         <p:blipFill>
-          <a:blip xmlns:r="http://schemas.openxmlformats.org/officeDocument/2006/relationships" xmlns:a="http://schemas.openxmlformats.org/drawingml/2006/main" r:embed="R7096bef944d943fb"/>
+          <a:blip xmlns:r="http://schemas.openxmlformats.org/officeDocument/2006/relationships" xmlns:a="http://schemas.openxmlformats.org/drawingml/2006/main" r:embed="R6cfab83bdb3a4814"/>
           <a:stretch xmlns:a="http://schemas.openxmlformats.org/drawingml/2006/main">
             <a:fillRect l="0" t="0" r="0" b="0"/>
           </a:stretch>
@@ -4856,7 +4856,7 @@
           <p:nvPr/>
         </p:nvPicPr>
         <p:blipFill>
-          <a:blip xmlns:r="http://schemas.openxmlformats.org/officeDocument/2006/relationships" xmlns:a="http://schemas.openxmlformats.org/drawingml/2006/main" r:embed="Rb8a78655cd1241f6"/>
+          <a:blip xmlns:r="http://schemas.openxmlformats.org/officeDocument/2006/relationships" xmlns:a="http://schemas.openxmlformats.org/drawingml/2006/main" r:embed="R3cc890c6dc6740f3"/>
           <a:stretch xmlns:a="http://schemas.openxmlformats.org/drawingml/2006/main">
             <a:fillRect l="0" t="0" r="0" b="0"/>
           </a:stretch>

</xml_diff>

<commit_message>
Refine resident silhouettes and grounded movement
</commit_message>
<xml_diff>
--- a/docs/deck/Kampung SG-Project Introduction Deck-TheTwoGuys.pptx
+++ b/docs/deck/Kampung SG-Project Introduction Deck-TheTwoGuys.pptx
@@ -2,20 +2,20 @@
 <file path=ppt/presentation.xml><?xml version="1.0" encoding="utf-8"?>
 <p:presentation xmlns:p="http://schemas.openxmlformats.org/presentationml/2006/main">
   <p:sldMasterIdLst>
-    <p:sldMasterId xmlns:r="http://schemas.openxmlformats.org/officeDocument/2006/relationships" id="2147483648" r:id="Rb7f2cd2f24fe4684"/>
+    <p:sldMasterId xmlns:r="http://schemas.openxmlformats.org/officeDocument/2006/relationships" id="2147483648" r:id="Ra74a103996894160"/>
   </p:sldMasterIdLst>
   <p:notesMasterIdLst>
-    <p:notesMasterId xmlns:r="http://schemas.openxmlformats.org/officeDocument/2006/relationships" r:id="R037b44cdb8854921"/>
+    <p:notesMasterId xmlns:r="http://schemas.openxmlformats.org/officeDocument/2006/relationships" r:id="Rd5cbd2bc84554d8f"/>
   </p:notesMasterIdLst>
   <p:sldIdLst>
-    <p:sldId xmlns:r="http://schemas.openxmlformats.org/officeDocument/2006/relationships" id="256" r:id="R6106e07d8f05459e"/>
-    <p:sldId xmlns:r="http://schemas.openxmlformats.org/officeDocument/2006/relationships" id="257" r:id="R5f36cc8919c24ace"/>
-    <p:sldId xmlns:r="http://schemas.openxmlformats.org/officeDocument/2006/relationships" id="258" r:id="R507c66c0e45f4094"/>
-    <p:sldId xmlns:r="http://schemas.openxmlformats.org/officeDocument/2006/relationships" id="259" r:id="R08b28c0c04114654"/>
-    <p:sldId xmlns:r="http://schemas.openxmlformats.org/officeDocument/2006/relationships" id="260" r:id="Rb9b2248bfaed4c29"/>
-    <p:sldId xmlns:r="http://schemas.openxmlformats.org/officeDocument/2006/relationships" id="261" r:id="Ra246e705de954265"/>
-    <p:sldId xmlns:r="http://schemas.openxmlformats.org/officeDocument/2006/relationships" id="262" r:id="Rab9a2cf825094078"/>
-    <p:sldId xmlns:r="http://schemas.openxmlformats.org/officeDocument/2006/relationships" id="263" r:id="R180532b55f184e9c"/>
+    <p:sldId xmlns:r="http://schemas.openxmlformats.org/officeDocument/2006/relationships" id="256" r:id="R7d326e802909479f"/>
+    <p:sldId xmlns:r="http://schemas.openxmlformats.org/officeDocument/2006/relationships" id="257" r:id="Ra7088ae5f0ec4401"/>
+    <p:sldId xmlns:r="http://schemas.openxmlformats.org/officeDocument/2006/relationships" id="258" r:id="Rd0b7df72363d44bd"/>
+    <p:sldId xmlns:r="http://schemas.openxmlformats.org/officeDocument/2006/relationships" id="259" r:id="R5eabb91f6c3144c1"/>
+    <p:sldId xmlns:r="http://schemas.openxmlformats.org/officeDocument/2006/relationships" id="260" r:id="Raa093255151e4d4d"/>
+    <p:sldId xmlns:r="http://schemas.openxmlformats.org/officeDocument/2006/relationships" id="261" r:id="R85c984f8e13d407b"/>
+    <p:sldId xmlns:r="http://schemas.openxmlformats.org/officeDocument/2006/relationships" id="262" r:id="R6919e38c0d4f4b37"/>
+    <p:sldId xmlns:r="http://schemas.openxmlformats.org/officeDocument/2006/relationships" id="263" r:id="R8b2e8fc25aab4cb9"/>
   </p:sldIdLst>
   <p:sldSz cx="12191695" cy="6858000"/>
   <p:notesSz cx="6858000" cy="9144000"/>
@@ -847,7 +847,7 @@
           <a:lstStyle xmlns:a="http://schemas.openxmlformats.org/drawingml/2006/main"/>
           <a:p xmlns:a="http://schemas.openxmlformats.org/drawingml/2006/main">
             <a:r>
-              <a:t>Our first CodeBuddy run failed its gate, and the correction attempt hit 429 credits exhausted. We preserved that evidence. Later AI-assisted work added the pure campaign reducer, KampungMind and expanded checks. A real OpenAI image-generation pass produced one visual target; human review rejected direct runtime use and translated its strongest idea into four verified code-drawn activity vignettes. We treat AI output as a pull request, not a deliverable, and we do not relabel this as Miora.</a:t>
+              <a:t>Our first CodeBuddy run failed its gate, and the correction attempt hit 429 credits exhausted. We preserved that evidence. Later AI-assisted work added the pure campaign reducer, KampungMind and expanded checks. Four real OpenAI image-generation workflows produced visual direction for the title, activity density, estate prop clusters, and resident silhouettes. Human review rejected direct runtime use and translated selected ideas into three original code-drawn systems, including four verified activity vignettes and the authored resident cast grammar. We treat AI output as a pull request, not a deliverable, and we do not relabel this as Miora.</a:t>
             </a:r>
           </a:p>
         </p:txBody>
@@ -4013,17 +4013,17 @@
   </p:cSld>
   <p:clrMap bg1="lt1" tx1="dk1" bg2="lt2" tx2="dk2" accent1="accent1" accent2="accent2" accent3="accent3" accent4="accent4" accent5="accent5" accent6="accent6" hlink="hlink" folHlink="folHlink"/>
   <p:sldLayoutIdLst>
-    <p:sldLayoutId xmlns:r="http://schemas.openxmlformats.org/officeDocument/2006/relationships" id="2147483649" r:id="Rb82aa42c8af741f9"/>
-    <p:sldLayoutId xmlns:r="http://schemas.openxmlformats.org/officeDocument/2006/relationships" id="2147483650" r:id="Rd5ecd062d8214819"/>
-    <p:sldLayoutId xmlns:r="http://schemas.openxmlformats.org/officeDocument/2006/relationships" id="2147483651" r:id="R5c14f1fa2a134d74"/>
-    <p:sldLayoutId xmlns:r="http://schemas.openxmlformats.org/officeDocument/2006/relationships" id="2147483652" r:id="Rfe1cb46f10ba4e0d"/>
-    <p:sldLayoutId xmlns:r="http://schemas.openxmlformats.org/officeDocument/2006/relationships" id="2147483653" r:id="R4c8a89721b3c400d"/>
-    <p:sldLayoutId xmlns:r="http://schemas.openxmlformats.org/officeDocument/2006/relationships" id="2147483654" r:id="Re6b6c02075d249d5"/>
-    <p:sldLayoutId xmlns:r="http://schemas.openxmlformats.org/officeDocument/2006/relationships" id="2147483655" r:id="Re73efa3ae0ed42ae"/>
-    <p:sldLayoutId xmlns:r="http://schemas.openxmlformats.org/officeDocument/2006/relationships" id="2147483656" r:id="Rd2f58601855942a6"/>
-    <p:sldLayoutId xmlns:r="http://schemas.openxmlformats.org/officeDocument/2006/relationships" id="2147483657" r:id="R63d9e8800f8340ff"/>
-    <p:sldLayoutId xmlns:r="http://schemas.openxmlformats.org/officeDocument/2006/relationships" id="2147483658" r:id="R7cda7ca28cdc400a"/>
-    <p:sldLayoutId xmlns:r="http://schemas.openxmlformats.org/officeDocument/2006/relationships" id="2147483659" r:id="Rb937578abdc7473c"/>
+    <p:sldLayoutId xmlns:r="http://schemas.openxmlformats.org/officeDocument/2006/relationships" id="2147483649" r:id="R59f16239eb2d45e4"/>
+    <p:sldLayoutId xmlns:r="http://schemas.openxmlformats.org/officeDocument/2006/relationships" id="2147483650" r:id="R6c1e73b377864b27"/>
+    <p:sldLayoutId xmlns:r="http://schemas.openxmlformats.org/officeDocument/2006/relationships" id="2147483651" r:id="R925dea71d6204402"/>
+    <p:sldLayoutId xmlns:r="http://schemas.openxmlformats.org/officeDocument/2006/relationships" id="2147483652" r:id="Rc41efe91ed094a88"/>
+    <p:sldLayoutId xmlns:r="http://schemas.openxmlformats.org/officeDocument/2006/relationships" id="2147483653" r:id="Rdc0bd52d5288480f"/>
+    <p:sldLayoutId xmlns:r="http://schemas.openxmlformats.org/officeDocument/2006/relationships" id="2147483654" r:id="R1d0d37a1f4cf4731"/>
+    <p:sldLayoutId xmlns:r="http://schemas.openxmlformats.org/officeDocument/2006/relationships" id="2147483655" r:id="R67f333d1d7654d71"/>
+    <p:sldLayoutId xmlns:r="http://schemas.openxmlformats.org/officeDocument/2006/relationships" id="2147483656" r:id="Ra8c94761f4984b6c"/>
+    <p:sldLayoutId xmlns:r="http://schemas.openxmlformats.org/officeDocument/2006/relationships" id="2147483657" r:id="Rd8a035822d2f4651"/>
+    <p:sldLayoutId xmlns:r="http://schemas.openxmlformats.org/officeDocument/2006/relationships" id="2147483658" r:id="Re8a529eeb85d458a"/>
+    <p:sldLayoutId xmlns:r="http://schemas.openxmlformats.org/officeDocument/2006/relationships" id="2147483659" r:id="R0f525c8c0e2344b5"/>
   </p:sldLayoutIdLst>
   <p:txStyles>
     <p:titleStyle>
@@ -4534,7 +4534,7 @@
           <p:nvPr/>
         </p:nvPicPr>
         <p:blipFill>
-          <a:blip xmlns:r="http://schemas.openxmlformats.org/officeDocument/2006/relationships" xmlns:a="http://schemas.openxmlformats.org/drawingml/2006/main" r:embed="Rec94f3ebf3564cbc"/>
+          <a:blip xmlns:r="http://schemas.openxmlformats.org/officeDocument/2006/relationships" xmlns:a="http://schemas.openxmlformats.org/drawingml/2006/main" r:embed="R326f6dff4927494a"/>
           <a:stretch xmlns:a="http://schemas.openxmlformats.org/drawingml/2006/main">
             <a:fillRect l="0" t="0" r="0" b="0"/>
           </a:stretch>
@@ -4580,7 +4580,7 @@
           <p:nvPr/>
         </p:nvPicPr>
         <p:blipFill>
-          <a:blip xmlns:r="http://schemas.openxmlformats.org/officeDocument/2006/relationships" xmlns:a="http://schemas.openxmlformats.org/drawingml/2006/main" r:embed="Rf18456af303e42b1"/>
+          <a:blip xmlns:r="http://schemas.openxmlformats.org/officeDocument/2006/relationships" xmlns:a="http://schemas.openxmlformats.org/drawingml/2006/main" r:embed="R04d412d8a0a6442f"/>
           <a:stretch xmlns:a="http://schemas.openxmlformats.org/drawingml/2006/main">
             <a:fillRect l="0" t="0" r="0" b="0"/>
           </a:stretch>
@@ -4626,7 +4626,7 @@
           <p:nvPr/>
         </p:nvPicPr>
         <p:blipFill>
-          <a:blip xmlns:r="http://schemas.openxmlformats.org/officeDocument/2006/relationships" xmlns:a="http://schemas.openxmlformats.org/drawingml/2006/main" r:embed="R345c4c3aa2b5485f"/>
+          <a:blip xmlns:r="http://schemas.openxmlformats.org/officeDocument/2006/relationships" xmlns:a="http://schemas.openxmlformats.org/drawingml/2006/main" r:embed="R1d9afb12d2c84e21"/>
           <a:stretch xmlns:a="http://schemas.openxmlformats.org/drawingml/2006/main">
             <a:fillRect l="0" t="0" r="0" b="0"/>
           </a:stretch>
@@ -4672,7 +4672,7 @@
           <p:nvPr/>
         </p:nvPicPr>
         <p:blipFill>
-          <a:blip xmlns:r="http://schemas.openxmlformats.org/officeDocument/2006/relationships" xmlns:a="http://schemas.openxmlformats.org/drawingml/2006/main" r:embed="R920c19da49f74581"/>
+          <a:blip xmlns:r="http://schemas.openxmlformats.org/officeDocument/2006/relationships" xmlns:a="http://schemas.openxmlformats.org/drawingml/2006/main" r:embed="R1ad6b2a1f2414372"/>
           <a:stretch xmlns:a="http://schemas.openxmlformats.org/drawingml/2006/main">
             <a:fillRect l="0" t="0" r="0" b="0"/>
           </a:stretch>
@@ -4718,7 +4718,7 @@
           <p:nvPr/>
         </p:nvPicPr>
         <p:blipFill>
-          <a:blip xmlns:r="http://schemas.openxmlformats.org/officeDocument/2006/relationships" xmlns:a="http://schemas.openxmlformats.org/drawingml/2006/main" r:embed="Reda50fdbf8994adb"/>
+          <a:blip xmlns:r="http://schemas.openxmlformats.org/officeDocument/2006/relationships" xmlns:a="http://schemas.openxmlformats.org/drawingml/2006/main" r:embed="R809783d3962d4423"/>
           <a:stretch xmlns:a="http://schemas.openxmlformats.org/drawingml/2006/main">
             <a:fillRect l="0" t="0" r="0" b="0"/>
           </a:stretch>
@@ -4764,7 +4764,7 @@
           <p:nvPr/>
         </p:nvPicPr>
         <p:blipFill>
-          <a:blip xmlns:r="http://schemas.openxmlformats.org/officeDocument/2006/relationships" xmlns:a="http://schemas.openxmlformats.org/drawingml/2006/main" r:embed="R67fe57c2cfab46be"/>
+          <a:blip xmlns:r="http://schemas.openxmlformats.org/officeDocument/2006/relationships" xmlns:a="http://schemas.openxmlformats.org/drawingml/2006/main" r:embed="Rba3efdfc79d54c04"/>
           <a:stretch xmlns:a="http://schemas.openxmlformats.org/drawingml/2006/main">
             <a:fillRect l="0" t="0" r="0" b="0"/>
           </a:stretch>
@@ -4810,7 +4810,7 @@
           <p:nvPr/>
         </p:nvPicPr>
         <p:blipFill>
-          <a:blip xmlns:r="http://schemas.openxmlformats.org/officeDocument/2006/relationships" xmlns:a="http://schemas.openxmlformats.org/drawingml/2006/main" r:embed="R6cfab83bdb3a4814"/>
+          <a:blip xmlns:r="http://schemas.openxmlformats.org/officeDocument/2006/relationships" xmlns:a="http://schemas.openxmlformats.org/drawingml/2006/main" r:embed="Re1002f0d628745f5"/>
           <a:stretch xmlns:a="http://schemas.openxmlformats.org/drawingml/2006/main">
             <a:fillRect l="0" t="0" r="0" b="0"/>
           </a:stretch>
@@ -4856,7 +4856,7 @@
           <p:nvPr/>
         </p:nvPicPr>
         <p:blipFill>
-          <a:blip xmlns:r="http://schemas.openxmlformats.org/officeDocument/2006/relationships" xmlns:a="http://schemas.openxmlformats.org/drawingml/2006/main" r:embed="R3cc890c6dc6740f3"/>
+          <a:blip xmlns:r="http://schemas.openxmlformats.org/officeDocument/2006/relationships" xmlns:a="http://schemas.openxmlformats.org/drawingml/2006/main" r:embed="Rfffd77fbf3c54ae0"/>
           <a:stretch xmlns:a="http://schemas.openxmlformats.org/drawingml/2006/main">
             <a:fillRect l="0" t="0" r="0" b="0"/>
           </a:stretch>

</xml_diff>

<commit_message>
Polish Kampung SG campaign experience
Add visible world consequences, resilient lazy loading, mobile tap navigation, stronger accessibility contracts, expanded browser smoke coverage, and refreshed verified submission evidence.
</commit_message>
<xml_diff>
--- a/docs/deck/Kampung SG-Project Introduction Deck-TheTwoGuys.pptx
+++ b/docs/deck/Kampung SG-Project Introduction Deck-TheTwoGuys.pptx
@@ -2,20 +2,20 @@
 <file path=ppt/presentation.xml><?xml version="1.0" encoding="utf-8"?>
 <p:presentation xmlns:p="http://schemas.openxmlformats.org/presentationml/2006/main">
   <p:sldMasterIdLst>
-    <p:sldMasterId xmlns:r="http://schemas.openxmlformats.org/officeDocument/2006/relationships" id="2147483648" r:id="Ra74a103996894160"/>
+    <p:sldMasterId xmlns:r="http://schemas.openxmlformats.org/officeDocument/2006/relationships" id="2147483648" r:id="R12f2e8dbd28f4a86"/>
   </p:sldMasterIdLst>
   <p:notesMasterIdLst>
-    <p:notesMasterId xmlns:r="http://schemas.openxmlformats.org/officeDocument/2006/relationships" r:id="Rd5cbd2bc84554d8f"/>
+    <p:notesMasterId xmlns:r="http://schemas.openxmlformats.org/officeDocument/2006/relationships" r:id="Rd13d96c0265e4096"/>
   </p:notesMasterIdLst>
   <p:sldIdLst>
-    <p:sldId xmlns:r="http://schemas.openxmlformats.org/officeDocument/2006/relationships" id="256" r:id="R7d326e802909479f"/>
-    <p:sldId xmlns:r="http://schemas.openxmlformats.org/officeDocument/2006/relationships" id="257" r:id="Ra7088ae5f0ec4401"/>
-    <p:sldId xmlns:r="http://schemas.openxmlformats.org/officeDocument/2006/relationships" id="258" r:id="Rd0b7df72363d44bd"/>
-    <p:sldId xmlns:r="http://schemas.openxmlformats.org/officeDocument/2006/relationships" id="259" r:id="R5eabb91f6c3144c1"/>
-    <p:sldId xmlns:r="http://schemas.openxmlformats.org/officeDocument/2006/relationships" id="260" r:id="Raa093255151e4d4d"/>
-    <p:sldId xmlns:r="http://schemas.openxmlformats.org/officeDocument/2006/relationships" id="261" r:id="R85c984f8e13d407b"/>
-    <p:sldId xmlns:r="http://schemas.openxmlformats.org/officeDocument/2006/relationships" id="262" r:id="R6919e38c0d4f4b37"/>
-    <p:sldId xmlns:r="http://schemas.openxmlformats.org/officeDocument/2006/relationships" id="263" r:id="R8b2e8fc25aab4cb9"/>
+    <p:sldId xmlns:r="http://schemas.openxmlformats.org/officeDocument/2006/relationships" id="256" r:id="Rd3b3832091ff46d2"/>
+    <p:sldId xmlns:r="http://schemas.openxmlformats.org/officeDocument/2006/relationships" id="257" r:id="R1eb5ea89edcf4533"/>
+    <p:sldId xmlns:r="http://schemas.openxmlformats.org/officeDocument/2006/relationships" id="258" r:id="R44b0d49eae8d4b3b"/>
+    <p:sldId xmlns:r="http://schemas.openxmlformats.org/officeDocument/2006/relationships" id="259" r:id="R7ee1277332af4b4a"/>
+    <p:sldId xmlns:r="http://schemas.openxmlformats.org/officeDocument/2006/relationships" id="260" r:id="Ra8a84ab5a1ea4f6a"/>
+    <p:sldId xmlns:r="http://schemas.openxmlformats.org/officeDocument/2006/relationships" id="261" r:id="Rfefeafe6a2014c4c"/>
+    <p:sldId xmlns:r="http://schemas.openxmlformats.org/officeDocument/2006/relationships" id="262" r:id="R6f1a47f2abfe4ce5"/>
+    <p:sldId xmlns:r="http://schemas.openxmlformats.org/officeDocument/2006/relationships" id="263" r:id="Re8c87b4eb9924e41"/>
   </p:sldIdLst>
   <p:sldSz cx="12191695" cy="6858000"/>
   <p:notesSz cx="6858000" cy="9144000"/>
@@ -917,7 +917,7 @@
           <a:lstStyle xmlns:a="http://schemas.openxmlformats.org/drawingml/2006/main"/>
           <a:p xmlns:a="http://schemas.openxmlformats.org/drawingml/2006/main">
             <a:r>
-              <a:t>Strict TypeScript, 75 unit tests, 60 production-browser checks and zero known vulnerabilities support the current build. KampungMind and every save remain in the browser: no account, backend, analytics or personal-data collection. Audio is synthesized at runtime.</a:t>
+              <a:t>Strict TypeScript, 79 unit tests (27 campaign, 31 match, 17 audio and 4 accessibility), 60 production-browser checks and zero known vulnerabilities support the current build. The private build is 84.76 kB HTML (15.26 kB gzip), 114.37 kB initial JavaScript (35.06 kB gzip), and 1,609.14 kB lazy scene code (376.46 kB gzip). Connection-aware idle prefetch follows the title art; Start reuses one cached load with cancel/retry recovery. KampungMind and every save remain in the browser: no account, backend, analytics or personal-data collection. Audio is synthesized at runtime.</a:t>
             </a:r>
           </a:p>
         </p:txBody>
@@ -1057,7 +1057,7 @@
           <a:lstStyle xmlns:a="http://schemas.openxmlformats.org/drawingml/2006/main"/>
           <a:p xmlns:a="http://schemas.openxmlformats.org/drawingml/2006/main">
             <a:r>
-              <a:t>We are TheTwoGuys. The public repository contains the current code, prompts, failed-run record, claim guardrails and reproducible gate. The game is playable in a browser with no install or account. Every small act grows the kampung.</a:t>
+              <a:t>We are TheTwoGuys. The project source preserves the current code, prompts, failed-run record, claim guardrails and reproducible local gate. The public browser build remains playable with no install or account; this latest local polish pass still requires explicit release approval before deployment. Every small act grows the kampung.</a:t>
             </a:r>
           </a:p>
         </p:txBody>
@@ -4013,17 +4013,17 @@
   </p:cSld>
   <p:clrMap bg1="lt1" tx1="dk1" bg2="lt2" tx2="dk2" accent1="accent1" accent2="accent2" accent3="accent3" accent4="accent4" accent5="accent5" accent6="accent6" hlink="hlink" folHlink="folHlink"/>
   <p:sldLayoutIdLst>
-    <p:sldLayoutId xmlns:r="http://schemas.openxmlformats.org/officeDocument/2006/relationships" id="2147483649" r:id="R59f16239eb2d45e4"/>
-    <p:sldLayoutId xmlns:r="http://schemas.openxmlformats.org/officeDocument/2006/relationships" id="2147483650" r:id="R6c1e73b377864b27"/>
-    <p:sldLayoutId xmlns:r="http://schemas.openxmlformats.org/officeDocument/2006/relationships" id="2147483651" r:id="R925dea71d6204402"/>
-    <p:sldLayoutId xmlns:r="http://schemas.openxmlformats.org/officeDocument/2006/relationships" id="2147483652" r:id="Rc41efe91ed094a88"/>
-    <p:sldLayoutId xmlns:r="http://schemas.openxmlformats.org/officeDocument/2006/relationships" id="2147483653" r:id="Rdc0bd52d5288480f"/>
-    <p:sldLayoutId xmlns:r="http://schemas.openxmlformats.org/officeDocument/2006/relationships" id="2147483654" r:id="R1d0d37a1f4cf4731"/>
-    <p:sldLayoutId xmlns:r="http://schemas.openxmlformats.org/officeDocument/2006/relationships" id="2147483655" r:id="R67f333d1d7654d71"/>
-    <p:sldLayoutId xmlns:r="http://schemas.openxmlformats.org/officeDocument/2006/relationships" id="2147483656" r:id="Ra8c94761f4984b6c"/>
-    <p:sldLayoutId xmlns:r="http://schemas.openxmlformats.org/officeDocument/2006/relationships" id="2147483657" r:id="Rd8a035822d2f4651"/>
-    <p:sldLayoutId xmlns:r="http://schemas.openxmlformats.org/officeDocument/2006/relationships" id="2147483658" r:id="Re8a529eeb85d458a"/>
-    <p:sldLayoutId xmlns:r="http://schemas.openxmlformats.org/officeDocument/2006/relationships" id="2147483659" r:id="R0f525c8c0e2344b5"/>
+    <p:sldLayoutId xmlns:r="http://schemas.openxmlformats.org/officeDocument/2006/relationships" id="2147483649" r:id="Ra10aa9d43baf43c4"/>
+    <p:sldLayoutId xmlns:r="http://schemas.openxmlformats.org/officeDocument/2006/relationships" id="2147483650" r:id="R933e865443d54963"/>
+    <p:sldLayoutId xmlns:r="http://schemas.openxmlformats.org/officeDocument/2006/relationships" id="2147483651" r:id="R5f33f448bbc14442"/>
+    <p:sldLayoutId xmlns:r="http://schemas.openxmlformats.org/officeDocument/2006/relationships" id="2147483652" r:id="R058872a33bae49ec"/>
+    <p:sldLayoutId xmlns:r="http://schemas.openxmlformats.org/officeDocument/2006/relationships" id="2147483653" r:id="R3b413a92a6ba4a06"/>
+    <p:sldLayoutId xmlns:r="http://schemas.openxmlformats.org/officeDocument/2006/relationships" id="2147483654" r:id="R66760ea4885648e0"/>
+    <p:sldLayoutId xmlns:r="http://schemas.openxmlformats.org/officeDocument/2006/relationships" id="2147483655" r:id="R97ebf6e802ec4eec"/>
+    <p:sldLayoutId xmlns:r="http://schemas.openxmlformats.org/officeDocument/2006/relationships" id="2147483656" r:id="R79a0cc3ec0364b3b"/>
+    <p:sldLayoutId xmlns:r="http://schemas.openxmlformats.org/officeDocument/2006/relationships" id="2147483657" r:id="R4c5092b73c164b2d"/>
+    <p:sldLayoutId xmlns:r="http://schemas.openxmlformats.org/officeDocument/2006/relationships" id="2147483658" r:id="R147c302bd43c4155"/>
+    <p:sldLayoutId xmlns:r="http://schemas.openxmlformats.org/officeDocument/2006/relationships" id="2147483659" r:id="R4056af7935544428"/>
   </p:sldLayoutIdLst>
   <p:txStyles>
     <p:titleStyle>
@@ -4534,7 +4534,7 @@
           <p:nvPr/>
         </p:nvPicPr>
         <p:blipFill>
-          <a:blip xmlns:r="http://schemas.openxmlformats.org/officeDocument/2006/relationships" xmlns:a="http://schemas.openxmlformats.org/drawingml/2006/main" r:embed="R326f6dff4927494a"/>
+          <a:blip xmlns:r="http://schemas.openxmlformats.org/officeDocument/2006/relationships" xmlns:a="http://schemas.openxmlformats.org/drawingml/2006/main" r:embed="Rca97075f1d404f79"/>
           <a:stretch xmlns:a="http://schemas.openxmlformats.org/drawingml/2006/main">
             <a:fillRect l="0" t="0" r="0" b="0"/>
           </a:stretch>
@@ -4580,7 +4580,7 @@
           <p:nvPr/>
         </p:nvPicPr>
         <p:blipFill>
-          <a:blip xmlns:r="http://schemas.openxmlformats.org/officeDocument/2006/relationships" xmlns:a="http://schemas.openxmlformats.org/drawingml/2006/main" r:embed="R04d412d8a0a6442f"/>
+          <a:blip xmlns:r="http://schemas.openxmlformats.org/officeDocument/2006/relationships" xmlns:a="http://schemas.openxmlformats.org/drawingml/2006/main" r:embed="Rafde39d97bcc43fd"/>
           <a:stretch xmlns:a="http://schemas.openxmlformats.org/drawingml/2006/main">
             <a:fillRect l="0" t="0" r="0" b="0"/>
           </a:stretch>
@@ -4626,7 +4626,7 @@
           <p:nvPr/>
         </p:nvPicPr>
         <p:blipFill>
-          <a:blip xmlns:r="http://schemas.openxmlformats.org/officeDocument/2006/relationships" xmlns:a="http://schemas.openxmlformats.org/drawingml/2006/main" r:embed="R1d9afb12d2c84e21"/>
+          <a:blip xmlns:r="http://schemas.openxmlformats.org/officeDocument/2006/relationships" xmlns:a="http://schemas.openxmlformats.org/drawingml/2006/main" r:embed="Rf18ae844894443c4"/>
           <a:stretch xmlns:a="http://schemas.openxmlformats.org/drawingml/2006/main">
             <a:fillRect l="0" t="0" r="0" b="0"/>
           </a:stretch>
@@ -4672,7 +4672,7 @@
           <p:nvPr/>
         </p:nvPicPr>
         <p:blipFill>
-          <a:blip xmlns:r="http://schemas.openxmlformats.org/officeDocument/2006/relationships" xmlns:a="http://schemas.openxmlformats.org/drawingml/2006/main" r:embed="R1ad6b2a1f2414372"/>
+          <a:blip xmlns:r="http://schemas.openxmlformats.org/officeDocument/2006/relationships" xmlns:a="http://schemas.openxmlformats.org/drawingml/2006/main" r:embed="Rd94c0b416d2d422d"/>
           <a:stretch xmlns:a="http://schemas.openxmlformats.org/drawingml/2006/main">
             <a:fillRect l="0" t="0" r="0" b="0"/>
           </a:stretch>
@@ -4718,7 +4718,7 @@
           <p:nvPr/>
         </p:nvPicPr>
         <p:blipFill>
-          <a:blip xmlns:r="http://schemas.openxmlformats.org/officeDocument/2006/relationships" xmlns:a="http://schemas.openxmlformats.org/drawingml/2006/main" r:embed="R809783d3962d4423"/>
+          <a:blip xmlns:r="http://schemas.openxmlformats.org/officeDocument/2006/relationships" xmlns:a="http://schemas.openxmlformats.org/drawingml/2006/main" r:embed="R9510c8037eab47bc"/>
           <a:stretch xmlns:a="http://schemas.openxmlformats.org/drawingml/2006/main">
             <a:fillRect l="0" t="0" r="0" b="0"/>
           </a:stretch>
@@ -4764,7 +4764,7 @@
           <p:nvPr/>
         </p:nvPicPr>
         <p:blipFill>
-          <a:blip xmlns:r="http://schemas.openxmlformats.org/officeDocument/2006/relationships" xmlns:a="http://schemas.openxmlformats.org/drawingml/2006/main" r:embed="Rba3efdfc79d54c04"/>
+          <a:blip xmlns:r="http://schemas.openxmlformats.org/officeDocument/2006/relationships" xmlns:a="http://schemas.openxmlformats.org/drawingml/2006/main" r:embed="R0a9706d59d524b8d"/>
           <a:stretch xmlns:a="http://schemas.openxmlformats.org/drawingml/2006/main">
             <a:fillRect l="0" t="0" r="0" b="0"/>
           </a:stretch>
@@ -4810,7 +4810,7 @@
           <p:nvPr/>
         </p:nvPicPr>
         <p:blipFill>
-          <a:blip xmlns:r="http://schemas.openxmlformats.org/officeDocument/2006/relationships" xmlns:a="http://schemas.openxmlformats.org/drawingml/2006/main" r:embed="Re1002f0d628745f5"/>
+          <a:blip xmlns:r="http://schemas.openxmlformats.org/officeDocument/2006/relationships" xmlns:a="http://schemas.openxmlformats.org/drawingml/2006/main" r:embed="R6cc9719ceb5f41f7"/>
           <a:stretch xmlns:a="http://schemas.openxmlformats.org/drawingml/2006/main">
             <a:fillRect l="0" t="0" r="0" b="0"/>
           </a:stretch>
@@ -4856,7 +4856,7 @@
           <p:nvPr/>
         </p:nvPicPr>
         <p:blipFill>
-          <a:blip xmlns:r="http://schemas.openxmlformats.org/officeDocument/2006/relationships" xmlns:a="http://schemas.openxmlformats.org/drawingml/2006/main" r:embed="Rfffd77fbf3c54ae0"/>
+          <a:blip xmlns:r="http://schemas.openxmlformats.org/officeDocument/2006/relationships" xmlns:a="http://schemas.openxmlformats.org/drawingml/2006/main" r:embed="R07f2b5e504a442b4"/>
           <a:stretch xmlns:a="http://schemas.openxmlformats.org/drawingml/2006/main">
             <a:fillRect l="0" t="0" r="0" b="0"/>
           </a:stretch>

</xml_diff>

<commit_message>
Polish full-viewport estate HUD
Centralize tree, lamp, and apron fixtures with pure layout audits; make every interface layer fill the dynamic viewport; and add automatic story plus optional-request tracking beneath the minimap.

Verified with strict TypeScript, 90/90 unit tests, production build, zero-vulnerability audit, and 60/60 browser routes in default WebGL and forced Canvas.
</commit_message>
<xml_diff>
--- a/docs/deck/Kampung SG-Project Introduction Deck-TheTwoGuys.pptx
+++ b/docs/deck/Kampung SG-Project Introduction Deck-TheTwoGuys.pptx
@@ -2,20 +2,20 @@
 <file path=ppt/presentation.xml><?xml version="1.0" encoding="utf-8"?>
 <p:presentation xmlns:p="http://schemas.openxmlformats.org/presentationml/2006/main">
   <p:sldMasterIdLst>
-    <p:sldMasterId xmlns:r="http://schemas.openxmlformats.org/officeDocument/2006/relationships" id="2147483648" r:id="R12f2e8dbd28f4a86"/>
+    <p:sldMasterId xmlns:r="http://schemas.openxmlformats.org/officeDocument/2006/relationships" id="2147483648" r:id="R9655ec070a2e4086"/>
   </p:sldMasterIdLst>
   <p:notesMasterIdLst>
-    <p:notesMasterId xmlns:r="http://schemas.openxmlformats.org/officeDocument/2006/relationships" r:id="Rd13d96c0265e4096"/>
+    <p:notesMasterId xmlns:r="http://schemas.openxmlformats.org/officeDocument/2006/relationships" r:id="R19715af8325c4344"/>
   </p:notesMasterIdLst>
   <p:sldIdLst>
-    <p:sldId xmlns:r="http://schemas.openxmlformats.org/officeDocument/2006/relationships" id="256" r:id="Rd3b3832091ff46d2"/>
-    <p:sldId xmlns:r="http://schemas.openxmlformats.org/officeDocument/2006/relationships" id="257" r:id="R1eb5ea89edcf4533"/>
-    <p:sldId xmlns:r="http://schemas.openxmlformats.org/officeDocument/2006/relationships" id="258" r:id="R44b0d49eae8d4b3b"/>
-    <p:sldId xmlns:r="http://schemas.openxmlformats.org/officeDocument/2006/relationships" id="259" r:id="R7ee1277332af4b4a"/>
-    <p:sldId xmlns:r="http://schemas.openxmlformats.org/officeDocument/2006/relationships" id="260" r:id="Ra8a84ab5a1ea4f6a"/>
-    <p:sldId xmlns:r="http://schemas.openxmlformats.org/officeDocument/2006/relationships" id="261" r:id="Rfefeafe6a2014c4c"/>
-    <p:sldId xmlns:r="http://schemas.openxmlformats.org/officeDocument/2006/relationships" id="262" r:id="R6f1a47f2abfe4ce5"/>
-    <p:sldId xmlns:r="http://schemas.openxmlformats.org/officeDocument/2006/relationships" id="263" r:id="Re8c87b4eb9924e41"/>
+    <p:sldId xmlns:r="http://schemas.openxmlformats.org/officeDocument/2006/relationships" id="256" r:id="R11557d0f54184bdc"/>
+    <p:sldId xmlns:r="http://schemas.openxmlformats.org/officeDocument/2006/relationships" id="257" r:id="Rfdc79e3f28d74e69"/>
+    <p:sldId xmlns:r="http://schemas.openxmlformats.org/officeDocument/2006/relationships" id="258" r:id="Rc0f69c19d1f8449e"/>
+    <p:sldId xmlns:r="http://schemas.openxmlformats.org/officeDocument/2006/relationships" id="259" r:id="Rfac61e3e6f6d4e38"/>
+    <p:sldId xmlns:r="http://schemas.openxmlformats.org/officeDocument/2006/relationships" id="260" r:id="R4372e52057c94162"/>
+    <p:sldId xmlns:r="http://schemas.openxmlformats.org/officeDocument/2006/relationships" id="261" r:id="Re959289359be41a0"/>
+    <p:sldId xmlns:r="http://schemas.openxmlformats.org/officeDocument/2006/relationships" id="262" r:id="R7fc743538f44430b"/>
+    <p:sldId xmlns:r="http://schemas.openxmlformats.org/officeDocument/2006/relationships" id="263" r:id="R565871cfe27741b0"/>
   </p:sldIdLst>
   <p:sldSz cx="12191695" cy="6858000"/>
   <p:notesSz cx="6858000" cy="9144000"/>
@@ -917,7 +917,7 @@
           <a:lstStyle xmlns:a="http://schemas.openxmlformats.org/drawingml/2006/main"/>
           <a:p xmlns:a="http://schemas.openxmlformats.org/drawingml/2006/main">
             <a:r>
-              <a:t>Strict TypeScript, 79 unit tests (27 campaign, 31 match, 17 audio and 4 accessibility), 60 production-browser checks and zero known vulnerabilities support the current build. The private build is 84.76 kB HTML (15.26 kB gzip), 114.37 kB initial JavaScript (35.06 kB gzip), and 1,609.14 kB lazy scene code (376.46 kB gzip). Connection-aware idle prefetch follows the title art; Start reuses one cached load with cancel/retry recovery. KampungMind and every save remain in the browser: no account, backend, analytics or personal-data collection. Audio is synthesized at runtime.</a:t>
+              <a:t>Strict TypeScript, 90 unit tests (30 campaign, 31 match, 17 audio, 4 accessibility and 8 world-layout), 60 production-browser checks and zero known vulnerabilities support the current build. The private build is 93.04 kB HTML (16.28 kB gzip), 135.02 kB initial JavaScript (39.95 kB gzip), and 1,602.10 kB lazy scene code (374.15 kB gzip). Connection-aware idle prefetch follows the title art; Start reuses one cached load with cancel/retry recovery. KampungMind and every save remain in the browser: no account, backend, analytics or personal-data collection. Audio is synthesized at runtime.</a:t>
             </a:r>
           </a:p>
         </p:txBody>
@@ -4013,17 +4013,17 @@
   </p:cSld>
   <p:clrMap bg1="lt1" tx1="dk1" bg2="lt2" tx2="dk2" accent1="accent1" accent2="accent2" accent3="accent3" accent4="accent4" accent5="accent5" accent6="accent6" hlink="hlink" folHlink="folHlink"/>
   <p:sldLayoutIdLst>
-    <p:sldLayoutId xmlns:r="http://schemas.openxmlformats.org/officeDocument/2006/relationships" id="2147483649" r:id="Ra10aa9d43baf43c4"/>
-    <p:sldLayoutId xmlns:r="http://schemas.openxmlformats.org/officeDocument/2006/relationships" id="2147483650" r:id="R933e865443d54963"/>
-    <p:sldLayoutId xmlns:r="http://schemas.openxmlformats.org/officeDocument/2006/relationships" id="2147483651" r:id="R5f33f448bbc14442"/>
-    <p:sldLayoutId xmlns:r="http://schemas.openxmlformats.org/officeDocument/2006/relationships" id="2147483652" r:id="R058872a33bae49ec"/>
-    <p:sldLayoutId xmlns:r="http://schemas.openxmlformats.org/officeDocument/2006/relationships" id="2147483653" r:id="R3b413a92a6ba4a06"/>
-    <p:sldLayoutId xmlns:r="http://schemas.openxmlformats.org/officeDocument/2006/relationships" id="2147483654" r:id="R66760ea4885648e0"/>
-    <p:sldLayoutId xmlns:r="http://schemas.openxmlformats.org/officeDocument/2006/relationships" id="2147483655" r:id="R97ebf6e802ec4eec"/>
-    <p:sldLayoutId xmlns:r="http://schemas.openxmlformats.org/officeDocument/2006/relationships" id="2147483656" r:id="R79a0cc3ec0364b3b"/>
-    <p:sldLayoutId xmlns:r="http://schemas.openxmlformats.org/officeDocument/2006/relationships" id="2147483657" r:id="R4c5092b73c164b2d"/>
-    <p:sldLayoutId xmlns:r="http://schemas.openxmlformats.org/officeDocument/2006/relationships" id="2147483658" r:id="R147c302bd43c4155"/>
-    <p:sldLayoutId xmlns:r="http://schemas.openxmlformats.org/officeDocument/2006/relationships" id="2147483659" r:id="R4056af7935544428"/>
+    <p:sldLayoutId xmlns:r="http://schemas.openxmlformats.org/officeDocument/2006/relationships" id="2147483649" r:id="R505e9f69d18c459a"/>
+    <p:sldLayoutId xmlns:r="http://schemas.openxmlformats.org/officeDocument/2006/relationships" id="2147483650" r:id="R4adab18cfa44435a"/>
+    <p:sldLayoutId xmlns:r="http://schemas.openxmlformats.org/officeDocument/2006/relationships" id="2147483651" r:id="Rc0fc06b8a96843dd"/>
+    <p:sldLayoutId xmlns:r="http://schemas.openxmlformats.org/officeDocument/2006/relationships" id="2147483652" r:id="R6f3884903c9b44dd"/>
+    <p:sldLayoutId xmlns:r="http://schemas.openxmlformats.org/officeDocument/2006/relationships" id="2147483653" r:id="R280e74ef535d442f"/>
+    <p:sldLayoutId xmlns:r="http://schemas.openxmlformats.org/officeDocument/2006/relationships" id="2147483654" r:id="R1f647cd5c60044ab"/>
+    <p:sldLayoutId xmlns:r="http://schemas.openxmlformats.org/officeDocument/2006/relationships" id="2147483655" r:id="R81732b8bc3ce45cb"/>
+    <p:sldLayoutId xmlns:r="http://schemas.openxmlformats.org/officeDocument/2006/relationships" id="2147483656" r:id="R9d1910f422ee4b78"/>
+    <p:sldLayoutId xmlns:r="http://schemas.openxmlformats.org/officeDocument/2006/relationships" id="2147483657" r:id="Rb91841cd0eed4e63"/>
+    <p:sldLayoutId xmlns:r="http://schemas.openxmlformats.org/officeDocument/2006/relationships" id="2147483658" r:id="R0c191a62152e4b22"/>
+    <p:sldLayoutId xmlns:r="http://schemas.openxmlformats.org/officeDocument/2006/relationships" id="2147483659" r:id="R39c42da99a514826"/>
   </p:sldLayoutIdLst>
   <p:txStyles>
     <p:titleStyle>
@@ -4534,7 +4534,7 @@
           <p:nvPr/>
         </p:nvPicPr>
         <p:blipFill>
-          <a:blip xmlns:r="http://schemas.openxmlformats.org/officeDocument/2006/relationships" xmlns:a="http://schemas.openxmlformats.org/drawingml/2006/main" r:embed="Rca97075f1d404f79"/>
+          <a:blip xmlns:r="http://schemas.openxmlformats.org/officeDocument/2006/relationships" xmlns:a="http://schemas.openxmlformats.org/drawingml/2006/main" r:embed="R45c8f1b83ab34c0f"/>
           <a:stretch xmlns:a="http://schemas.openxmlformats.org/drawingml/2006/main">
             <a:fillRect l="0" t="0" r="0" b="0"/>
           </a:stretch>
@@ -4580,7 +4580,7 @@
           <p:nvPr/>
         </p:nvPicPr>
         <p:blipFill>
-          <a:blip xmlns:r="http://schemas.openxmlformats.org/officeDocument/2006/relationships" xmlns:a="http://schemas.openxmlformats.org/drawingml/2006/main" r:embed="Rafde39d97bcc43fd"/>
+          <a:blip xmlns:r="http://schemas.openxmlformats.org/officeDocument/2006/relationships" xmlns:a="http://schemas.openxmlformats.org/drawingml/2006/main" r:embed="R4b2e088239c44fd1"/>
           <a:stretch xmlns:a="http://schemas.openxmlformats.org/drawingml/2006/main">
             <a:fillRect l="0" t="0" r="0" b="0"/>
           </a:stretch>
@@ -4626,7 +4626,7 @@
           <p:nvPr/>
         </p:nvPicPr>
         <p:blipFill>
-          <a:blip xmlns:r="http://schemas.openxmlformats.org/officeDocument/2006/relationships" xmlns:a="http://schemas.openxmlformats.org/drawingml/2006/main" r:embed="Rf18ae844894443c4"/>
+          <a:blip xmlns:r="http://schemas.openxmlformats.org/officeDocument/2006/relationships" xmlns:a="http://schemas.openxmlformats.org/drawingml/2006/main" r:embed="R7d683c62cfac439d"/>
           <a:stretch xmlns:a="http://schemas.openxmlformats.org/drawingml/2006/main">
             <a:fillRect l="0" t="0" r="0" b="0"/>
           </a:stretch>
@@ -4672,7 +4672,7 @@
           <p:nvPr/>
         </p:nvPicPr>
         <p:blipFill>
-          <a:blip xmlns:r="http://schemas.openxmlformats.org/officeDocument/2006/relationships" xmlns:a="http://schemas.openxmlformats.org/drawingml/2006/main" r:embed="Rd94c0b416d2d422d"/>
+          <a:blip xmlns:r="http://schemas.openxmlformats.org/officeDocument/2006/relationships" xmlns:a="http://schemas.openxmlformats.org/drawingml/2006/main" r:embed="Rd020c6752c714893"/>
           <a:stretch xmlns:a="http://schemas.openxmlformats.org/drawingml/2006/main">
             <a:fillRect l="0" t="0" r="0" b="0"/>
           </a:stretch>
@@ -4718,7 +4718,7 @@
           <p:nvPr/>
         </p:nvPicPr>
         <p:blipFill>
-          <a:blip xmlns:r="http://schemas.openxmlformats.org/officeDocument/2006/relationships" xmlns:a="http://schemas.openxmlformats.org/drawingml/2006/main" r:embed="R9510c8037eab47bc"/>
+          <a:blip xmlns:r="http://schemas.openxmlformats.org/officeDocument/2006/relationships" xmlns:a="http://schemas.openxmlformats.org/drawingml/2006/main" r:embed="R8b597d5e9a694091"/>
           <a:stretch xmlns:a="http://schemas.openxmlformats.org/drawingml/2006/main">
             <a:fillRect l="0" t="0" r="0" b="0"/>
           </a:stretch>
@@ -4764,7 +4764,7 @@
           <p:nvPr/>
         </p:nvPicPr>
         <p:blipFill>
-          <a:blip xmlns:r="http://schemas.openxmlformats.org/officeDocument/2006/relationships" xmlns:a="http://schemas.openxmlformats.org/drawingml/2006/main" r:embed="R0a9706d59d524b8d"/>
+          <a:blip xmlns:r="http://schemas.openxmlformats.org/officeDocument/2006/relationships" xmlns:a="http://schemas.openxmlformats.org/drawingml/2006/main" r:embed="Raefe6930897146c9"/>
           <a:stretch xmlns:a="http://schemas.openxmlformats.org/drawingml/2006/main">
             <a:fillRect l="0" t="0" r="0" b="0"/>
           </a:stretch>
@@ -4810,7 +4810,7 @@
           <p:nvPr/>
         </p:nvPicPr>
         <p:blipFill>
-          <a:blip xmlns:r="http://schemas.openxmlformats.org/officeDocument/2006/relationships" xmlns:a="http://schemas.openxmlformats.org/drawingml/2006/main" r:embed="R6cc9719ceb5f41f7"/>
+          <a:blip xmlns:r="http://schemas.openxmlformats.org/officeDocument/2006/relationships" xmlns:a="http://schemas.openxmlformats.org/drawingml/2006/main" r:embed="R32edfe983d9544b3"/>
           <a:stretch xmlns:a="http://schemas.openxmlformats.org/drawingml/2006/main">
             <a:fillRect l="0" t="0" r="0" b="0"/>
           </a:stretch>
@@ -4856,7 +4856,7 @@
           <p:nvPr/>
         </p:nvPicPr>
         <p:blipFill>
-          <a:blip xmlns:r="http://schemas.openxmlformats.org/officeDocument/2006/relationships" xmlns:a="http://schemas.openxmlformats.org/drawingml/2006/main" r:embed="R07f2b5e504a442b4"/>
+          <a:blip xmlns:r="http://schemas.openxmlformats.org/officeDocument/2006/relationships" xmlns:a="http://schemas.openxmlformats.org/drawingml/2006/main" r:embed="R2558ba43a84441c5"/>
           <a:stretch xmlns:a="http://schemas.openxmlformats.org/drawingml/2006/main">
             <a:fillRect l="0" t="0" r="0" b="0"/>
           </a:stretch>

</xml_diff>

<commit_message>
Restore game focus after pointer resume
</commit_message>
<xml_diff>
--- a/docs/deck/Kampung SG-Project Introduction Deck-TheTwoGuys.pptx
+++ b/docs/deck/Kampung SG-Project Introduction Deck-TheTwoGuys.pptx
@@ -2,20 +2,20 @@
 <file path=ppt/presentation.xml><?xml version="1.0" encoding="utf-8"?>
 <p:presentation xmlns:p="http://schemas.openxmlformats.org/presentationml/2006/main">
   <p:sldMasterIdLst>
-    <p:sldMasterId xmlns:r="http://schemas.openxmlformats.org/officeDocument/2006/relationships" id="2147483648" r:id="R9655ec070a2e4086"/>
+    <p:sldMasterId xmlns:r="http://schemas.openxmlformats.org/officeDocument/2006/relationships" id="2147483648" r:id="Re3ac9d0883b742b6"/>
   </p:sldMasterIdLst>
   <p:notesMasterIdLst>
-    <p:notesMasterId xmlns:r="http://schemas.openxmlformats.org/officeDocument/2006/relationships" r:id="R19715af8325c4344"/>
+    <p:notesMasterId xmlns:r="http://schemas.openxmlformats.org/officeDocument/2006/relationships" r:id="R11dd4010db9b43e0"/>
   </p:notesMasterIdLst>
   <p:sldIdLst>
-    <p:sldId xmlns:r="http://schemas.openxmlformats.org/officeDocument/2006/relationships" id="256" r:id="R11557d0f54184bdc"/>
-    <p:sldId xmlns:r="http://schemas.openxmlformats.org/officeDocument/2006/relationships" id="257" r:id="Rfdc79e3f28d74e69"/>
-    <p:sldId xmlns:r="http://schemas.openxmlformats.org/officeDocument/2006/relationships" id="258" r:id="Rc0f69c19d1f8449e"/>
-    <p:sldId xmlns:r="http://schemas.openxmlformats.org/officeDocument/2006/relationships" id="259" r:id="Rfac61e3e6f6d4e38"/>
-    <p:sldId xmlns:r="http://schemas.openxmlformats.org/officeDocument/2006/relationships" id="260" r:id="R4372e52057c94162"/>
-    <p:sldId xmlns:r="http://schemas.openxmlformats.org/officeDocument/2006/relationships" id="261" r:id="Re959289359be41a0"/>
-    <p:sldId xmlns:r="http://schemas.openxmlformats.org/officeDocument/2006/relationships" id="262" r:id="R7fc743538f44430b"/>
-    <p:sldId xmlns:r="http://schemas.openxmlformats.org/officeDocument/2006/relationships" id="263" r:id="R565871cfe27741b0"/>
+    <p:sldId xmlns:r="http://schemas.openxmlformats.org/officeDocument/2006/relationships" id="256" r:id="Rc2dc55cfa90a4f3d"/>
+    <p:sldId xmlns:r="http://schemas.openxmlformats.org/officeDocument/2006/relationships" id="257" r:id="R7568b8b0108a4690"/>
+    <p:sldId xmlns:r="http://schemas.openxmlformats.org/officeDocument/2006/relationships" id="258" r:id="R6cdabc06ab804db7"/>
+    <p:sldId xmlns:r="http://schemas.openxmlformats.org/officeDocument/2006/relationships" id="259" r:id="Rf5f22044205e4fde"/>
+    <p:sldId xmlns:r="http://schemas.openxmlformats.org/officeDocument/2006/relationships" id="260" r:id="Rd66b866d38eb4db8"/>
+    <p:sldId xmlns:r="http://schemas.openxmlformats.org/officeDocument/2006/relationships" id="261" r:id="Rb8f355cc37794267"/>
+    <p:sldId xmlns:r="http://schemas.openxmlformats.org/officeDocument/2006/relationships" id="262" r:id="R8e1bcb3d96264782"/>
+    <p:sldId xmlns:r="http://schemas.openxmlformats.org/officeDocument/2006/relationships" id="263" r:id="R7c95fc7d813c44bb"/>
   </p:sldIdLst>
   <p:sldSz cx="12191695" cy="6858000"/>
   <p:notesSz cx="6858000" cy="9144000"/>
@@ -917,7 +917,7 @@
           <a:lstStyle xmlns:a="http://schemas.openxmlformats.org/drawingml/2006/main"/>
           <a:p xmlns:a="http://schemas.openxmlformats.org/drawingml/2006/main">
             <a:r>
-              <a:t>Strict TypeScript, 90 unit tests (30 campaign, 31 match, 17 audio, 4 accessibility and 8 world-layout), 60 production-browser checks and zero known vulnerabilities support the current build. The private build is 93.04 kB HTML (16.28 kB gzip), 135.02 kB initial JavaScript (39.95 kB gzip), and 1,602.10 kB lazy scene code (374.15 kB gzip). Connection-aware idle prefetch follows the title art; Start reuses one cached load with cancel/retry recovery. KampungMind and every save remain in the browser: no account, backend, analytics or personal-data collection. Audio is synthesized at runtime.</a:t>
+              <a:t>Strict TypeScript, 90 unit tests (30 campaign, 31 match, 17 audio, 4 accessibility, and 8 world/door/pause), 60 production-browser checks in default WebGL and forced Canvas, and zero known vulnerabilities support the current build. The private build is 91.64 kB HTML (16.14 kB gzip), 141.46 kB initial JavaScript (41.48 kB gzip), and 1,613.26 kB lazy scene code (379.79 kB gzip). A real pointer Menu to Resume to Canvas round trip now proves focus and movement recovery while pointer-only decorative frames stay hidden and keyboard focus remains visible. KampungMind and every save remain in the browser: no account, backend, analytics or personal-data collection. Audio is synthesized at runtime.</a:t>
             </a:r>
           </a:p>
         </p:txBody>
@@ -4013,17 +4013,17 @@
   </p:cSld>
   <p:clrMap bg1="lt1" tx1="dk1" bg2="lt2" tx2="dk2" accent1="accent1" accent2="accent2" accent3="accent3" accent4="accent4" accent5="accent5" accent6="accent6" hlink="hlink" folHlink="folHlink"/>
   <p:sldLayoutIdLst>
-    <p:sldLayoutId xmlns:r="http://schemas.openxmlformats.org/officeDocument/2006/relationships" id="2147483649" r:id="R505e9f69d18c459a"/>
-    <p:sldLayoutId xmlns:r="http://schemas.openxmlformats.org/officeDocument/2006/relationships" id="2147483650" r:id="R4adab18cfa44435a"/>
-    <p:sldLayoutId xmlns:r="http://schemas.openxmlformats.org/officeDocument/2006/relationships" id="2147483651" r:id="Rc0fc06b8a96843dd"/>
-    <p:sldLayoutId xmlns:r="http://schemas.openxmlformats.org/officeDocument/2006/relationships" id="2147483652" r:id="R6f3884903c9b44dd"/>
-    <p:sldLayoutId xmlns:r="http://schemas.openxmlformats.org/officeDocument/2006/relationships" id="2147483653" r:id="R280e74ef535d442f"/>
-    <p:sldLayoutId xmlns:r="http://schemas.openxmlformats.org/officeDocument/2006/relationships" id="2147483654" r:id="R1f647cd5c60044ab"/>
-    <p:sldLayoutId xmlns:r="http://schemas.openxmlformats.org/officeDocument/2006/relationships" id="2147483655" r:id="R81732b8bc3ce45cb"/>
-    <p:sldLayoutId xmlns:r="http://schemas.openxmlformats.org/officeDocument/2006/relationships" id="2147483656" r:id="R9d1910f422ee4b78"/>
-    <p:sldLayoutId xmlns:r="http://schemas.openxmlformats.org/officeDocument/2006/relationships" id="2147483657" r:id="Rb91841cd0eed4e63"/>
-    <p:sldLayoutId xmlns:r="http://schemas.openxmlformats.org/officeDocument/2006/relationships" id="2147483658" r:id="R0c191a62152e4b22"/>
-    <p:sldLayoutId xmlns:r="http://schemas.openxmlformats.org/officeDocument/2006/relationships" id="2147483659" r:id="R39c42da99a514826"/>
+    <p:sldLayoutId xmlns:r="http://schemas.openxmlformats.org/officeDocument/2006/relationships" id="2147483649" r:id="R7d54d5c34aaa439f"/>
+    <p:sldLayoutId xmlns:r="http://schemas.openxmlformats.org/officeDocument/2006/relationships" id="2147483650" r:id="R2d4842c4b9fa4427"/>
+    <p:sldLayoutId xmlns:r="http://schemas.openxmlformats.org/officeDocument/2006/relationships" id="2147483651" r:id="Rbd463d7cbe374754"/>
+    <p:sldLayoutId xmlns:r="http://schemas.openxmlformats.org/officeDocument/2006/relationships" id="2147483652" r:id="R9b9ff31f93974d25"/>
+    <p:sldLayoutId xmlns:r="http://schemas.openxmlformats.org/officeDocument/2006/relationships" id="2147483653" r:id="Ra09f99e57c084e99"/>
+    <p:sldLayoutId xmlns:r="http://schemas.openxmlformats.org/officeDocument/2006/relationships" id="2147483654" r:id="Rc74075ffac2f49c1"/>
+    <p:sldLayoutId xmlns:r="http://schemas.openxmlformats.org/officeDocument/2006/relationships" id="2147483655" r:id="R08192c0911784dfe"/>
+    <p:sldLayoutId xmlns:r="http://schemas.openxmlformats.org/officeDocument/2006/relationships" id="2147483656" r:id="Rdb9e9a2a2f1f4cb6"/>
+    <p:sldLayoutId xmlns:r="http://schemas.openxmlformats.org/officeDocument/2006/relationships" id="2147483657" r:id="Rcfa32daa5bd84edd"/>
+    <p:sldLayoutId xmlns:r="http://schemas.openxmlformats.org/officeDocument/2006/relationships" id="2147483658" r:id="Rdd5f47a9706046c5"/>
+    <p:sldLayoutId xmlns:r="http://schemas.openxmlformats.org/officeDocument/2006/relationships" id="2147483659" r:id="Rd08eb97555444ea0"/>
   </p:sldLayoutIdLst>
   <p:txStyles>
     <p:titleStyle>
@@ -4534,7 +4534,7 @@
           <p:nvPr/>
         </p:nvPicPr>
         <p:blipFill>
-          <a:blip xmlns:r="http://schemas.openxmlformats.org/officeDocument/2006/relationships" xmlns:a="http://schemas.openxmlformats.org/drawingml/2006/main" r:embed="R45c8f1b83ab34c0f"/>
+          <a:blip xmlns:r="http://schemas.openxmlformats.org/officeDocument/2006/relationships" xmlns:a="http://schemas.openxmlformats.org/drawingml/2006/main" r:embed="R3acb2eb642044626"/>
           <a:stretch xmlns:a="http://schemas.openxmlformats.org/drawingml/2006/main">
             <a:fillRect l="0" t="0" r="0" b="0"/>
           </a:stretch>
@@ -4580,7 +4580,7 @@
           <p:nvPr/>
         </p:nvPicPr>
         <p:blipFill>
-          <a:blip xmlns:r="http://schemas.openxmlformats.org/officeDocument/2006/relationships" xmlns:a="http://schemas.openxmlformats.org/drawingml/2006/main" r:embed="R4b2e088239c44fd1"/>
+          <a:blip xmlns:r="http://schemas.openxmlformats.org/officeDocument/2006/relationships" xmlns:a="http://schemas.openxmlformats.org/drawingml/2006/main" r:embed="Rcbe9386cf36c4653"/>
           <a:stretch xmlns:a="http://schemas.openxmlformats.org/drawingml/2006/main">
             <a:fillRect l="0" t="0" r="0" b="0"/>
           </a:stretch>
@@ -4626,7 +4626,7 @@
           <p:nvPr/>
         </p:nvPicPr>
         <p:blipFill>
-          <a:blip xmlns:r="http://schemas.openxmlformats.org/officeDocument/2006/relationships" xmlns:a="http://schemas.openxmlformats.org/drawingml/2006/main" r:embed="R7d683c62cfac439d"/>
+          <a:blip xmlns:r="http://schemas.openxmlformats.org/officeDocument/2006/relationships" xmlns:a="http://schemas.openxmlformats.org/drawingml/2006/main" r:embed="R1b1f7989a75e4a50"/>
           <a:stretch xmlns:a="http://schemas.openxmlformats.org/drawingml/2006/main">
             <a:fillRect l="0" t="0" r="0" b="0"/>
           </a:stretch>
@@ -4672,7 +4672,7 @@
           <p:nvPr/>
         </p:nvPicPr>
         <p:blipFill>
-          <a:blip xmlns:r="http://schemas.openxmlformats.org/officeDocument/2006/relationships" xmlns:a="http://schemas.openxmlformats.org/drawingml/2006/main" r:embed="Rd020c6752c714893"/>
+          <a:blip xmlns:r="http://schemas.openxmlformats.org/officeDocument/2006/relationships" xmlns:a="http://schemas.openxmlformats.org/drawingml/2006/main" r:embed="R9aab5fcd08604c17"/>
           <a:stretch xmlns:a="http://schemas.openxmlformats.org/drawingml/2006/main">
             <a:fillRect l="0" t="0" r="0" b="0"/>
           </a:stretch>
@@ -4718,7 +4718,7 @@
           <p:nvPr/>
         </p:nvPicPr>
         <p:blipFill>
-          <a:blip xmlns:r="http://schemas.openxmlformats.org/officeDocument/2006/relationships" xmlns:a="http://schemas.openxmlformats.org/drawingml/2006/main" r:embed="R8b597d5e9a694091"/>
+          <a:blip xmlns:r="http://schemas.openxmlformats.org/officeDocument/2006/relationships" xmlns:a="http://schemas.openxmlformats.org/drawingml/2006/main" r:embed="Red0ee5dd8d0b4967"/>
           <a:stretch xmlns:a="http://schemas.openxmlformats.org/drawingml/2006/main">
             <a:fillRect l="0" t="0" r="0" b="0"/>
           </a:stretch>
@@ -4764,7 +4764,7 @@
           <p:nvPr/>
         </p:nvPicPr>
         <p:blipFill>
-          <a:blip xmlns:r="http://schemas.openxmlformats.org/officeDocument/2006/relationships" xmlns:a="http://schemas.openxmlformats.org/drawingml/2006/main" r:embed="Raefe6930897146c9"/>
+          <a:blip xmlns:r="http://schemas.openxmlformats.org/officeDocument/2006/relationships" xmlns:a="http://schemas.openxmlformats.org/drawingml/2006/main" r:embed="R5972c0521a904c02"/>
           <a:stretch xmlns:a="http://schemas.openxmlformats.org/drawingml/2006/main">
             <a:fillRect l="0" t="0" r="0" b="0"/>
           </a:stretch>
@@ -4810,7 +4810,7 @@
           <p:nvPr/>
         </p:nvPicPr>
         <p:blipFill>
-          <a:blip xmlns:r="http://schemas.openxmlformats.org/officeDocument/2006/relationships" xmlns:a="http://schemas.openxmlformats.org/drawingml/2006/main" r:embed="R32edfe983d9544b3"/>
+          <a:blip xmlns:r="http://schemas.openxmlformats.org/officeDocument/2006/relationships" xmlns:a="http://schemas.openxmlformats.org/drawingml/2006/main" r:embed="R2fe40247db024a88"/>
           <a:stretch xmlns:a="http://schemas.openxmlformats.org/drawingml/2006/main">
             <a:fillRect l="0" t="0" r="0" b="0"/>
           </a:stretch>
@@ -4856,7 +4856,7 @@
           <p:nvPr/>
         </p:nvPicPr>
         <p:blipFill>
-          <a:blip xmlns:r="http://schemas.openxmlformats.org/officeDocument/2006/relationships" xmlns:a="http://schemas.openxmlformats.org/drawingml/2006/main" r:embed="R2558ba43a84441c5"/>
+          <a:blip xmlns:r="http://schemas.openxmlformats.org/officeDocument/2006/relationships" xmlns:a="http://schemas.openxmlformats.org/drawingml/2006/main" r:embed="Rade0ce80c59643ce"/>
           <a:stretch xmlns:a="http://schemas.openxmlformats.org/drawingml/2006/main">
             <a:fillRect l="0" t="0" r="0" b="0"/>
           </a:stretch>

</xml_diff>